<commit_message>
Explain slide 09 gating experiments in plain Chinese
</commit_message>
<xml_diff>
--- a/presentations/slide09_confidence_gating_cn.pptx
+++ b/presentations/slide09_confidence_gating_cn.pptx
@@ -541,6 +541,21 @@
             </a:r>
           </a:p>
           <a:p/>
+          <a:p>
+            <a:r>
+              <a:t>通俗表达修订：页面移除AUC、OOF、rollout、反事实及Oracle等专有词，详细定义仍保留于以上备注。四行依次对应P5a、P5b、P5c与固定分歧门控；只有最后一行展示数值，且2.80→2.24来自同批评估。未展示不能部署的离线参考上界，未将不同批次直接排名。结论仅针对这些已试方案，不证明所有门控均无效。</a:t>
+            </a:r>
+          </a:p>
+          <a:p>
+            <a:r>
+              <a:t>通俗表达修订：页面移除AUC、OOF、rollout、反事实及Oracle等专有词，详细定义仍保留于以上备注。四行依次对应P5a、P5b、P5c与固定分歧门控；只有最后一行展示数值，且2.80→2.24来自同批评估。未展示不能部署的离线参考上界，未将不同批次直接排名。结论仅针对这些已试方案，不证明所有门控均无效。</a:t>
+            </a:r>
+          </a:p>
+          <a:p>
+            <a:r>
+              <a:t>通俗表达修订：页面移除AUC、OOF、rollout、反事实及Oracle等专有词，详细定义仍保留于以上备注。四行依次对应P5a、P5b、P5c与固定分歧门控；只有最后一行展示数值，且2.80→2.24来自同批评估。未展示不能部署的离线参考上界，未将不同批次直接排名。结论仅针对这些已试方案，不证明所有门控均无效。</a:t>
+            </a:r>
+          </a:p>
         </p:txBody>
       </p:sp>
       <p:sp>
@@ -3675,7 +3690,7 @@
               </a:defRPr>
             </a:pPr>
             <a:r>
-              <a:t>P5 / 置信度融合与自适应门控</a:t>
+              <a:t>P5 / 调整两种方向的信任程度</a:t>
             </a:r>
           </a:p>
         </p:txBody>
@@ -3707,7 +3722,7 @@
               <a:spcAft>
                 <a:spcPts val="700"/>
               </a:spcAft>
-              <a:defRPr sz="2700" b="1">
+              <a:defRPr sz="2900" b="1">
                 <a:solidFill>
                   <a:srgbClr val="142B46"/>
                 </a:solidFill>
@@ -3715,7 +3730,7 @@
               </a:defRPr>
             </a:pPr>
             <a:r>
-              <a:t>能否识别有害融合，并自适应减少 WP 权重？</a:t>
+              <a:t>什么时候应该少信航点方向？</a:t>
             </a:r>
           </a:p>
         </p:txBody>
@@ -3755,7 +3770,7 @@
               </a:defRPr>
             </a:pPr>
             <a:r>
-              <a:t>有害融合：ADE(κ 融合) &gt; ADE(仅 Goal) · 固定方向预测与主策略，研究融合规则</a:t>
+              <a:t>目标方向：目标在哪里 · 航点方向：接下来往哪里走 · 两者有时会相互冲突</a:t>
             </a:r>
           </a:p>
         </p:txBody>
@@ -3768,8 +3783,8 @@
         </p:nvSpPr>
         <p:spPr>
           <a:xfrm>
-            <a:off x="685800" y="2340864"/>
-            <a:ext cx="4142232" cy="813816"/>
+            <a:off x="685800" y="2249424"/>
+            <a:ext cx="10826496" cy="576072"/>
           </a:xfrm>
           <a:prstGeom prst="roundRect">
             <a:avLst>
@@ -3814,340 +3829,8 @@
         </p:nvSpPr>
         <p:spPr>
           <a:xfrm>
-            <a:off x="841248" y="2450592"/>
-            <a:ext cx="3831336" cy="283464"/>
-          </a:xfrm>
-          <a:prstGeom prst="rect">
-            <a:avLst/>
-          </a:prstGeom>
-          <a:noFill/>
-          <a:effectLst/>
-        </p:spPr>
-        <p:txBody>
-          <a:bodyPr wrap="none" lIns="0" rIns="0" tIns="0" bIns="0">
-            <a:spAutoFit/>
-          </a:bodyPr>
-          <a:lstStyle/>
-          <a:p>
-            <a:pPr>
-              <a:spcAft>
-                <a:spcPts val="700"/>
-              </a:spcAft>
-              <a:defRPr sz="1400" b="1">
-                <a:solidFill>
-                  <a:srgbClr val="142B46"/>
-                </a:solidFill>
-                <a:latin typeface="Noto Sans CJK SC"/>
-              </a:defRPr>
-            </a:pPr>
-            <a:r>
-              <a:t>P5a｜κ 权重份额解释力有限</a:t>
-            </a:r>
-          </a:p>
-        </p:txBody>
-      </p:sp>
-      <p:sp>
-        <p:nvSpPr>
-          <p:cNvPr id="9" name="TextBox 8"/>
-          <p:cNvSpPr txBox="1"/>
-          <p:nvPr/>
-        </p:nvSpPr>
-        <p:spPr>
-          <a:xfrm>
-            <a:off x="841248" y="2871216"/>
-            <a:ext cx="3831336" cy="228600"/>
-          </a:xfrm>
-          <a:prstGeom prst="rect">
-            <a:avLst/>
-          </a:prstGeom>
-          <a:noFill/>
-          <a:effectLst/>
-        </p:spPr>
-        <p:txBody>
-          <a:bodyPr wrap="none" lIns="0" rIns="0" tIns="0" bIns="0">
-            <a:spAutoFit/>
-          </a:bodyPr>
-          <a:lstStyle/>
-          <a:p>
-            <a:pPr>
-              <a:spcAft>
-                <a:spcPts val="700"/>
-              </a:spcAft>
-              <a:defRPr sz="1000" b="0">
-                <a:solidFill>
-                  <a:srgbClr val="62748A"/>
-                </a:solidFill>
-                <a:latin typeface="Noto Sans CJK SC"/>
-              </a:defRPr>
-            </a:pPr>
-            <a:r>
-              <a:t>有害 / 有益组的 WP 相对份额差异 d ≈ −0.04</a:t>
-            </a:r>
-          </a:p>
-        </p:txBody>
-      </p:sp>
-      <p:sp>
-        <p:nvSpPr>
-          <p:cNvPr id="10" name="Rounded Rectangle 9"/>
-          <p:cNvSpPr/>
-          <p:nvPr/>
-        </p:nvSpPr>
-        <p:spPr>
-          <a:xfrm>
-            <a:off x="685800" y="3374136"/>
-            <a:ext cx="4142232" cy="813816"/>
-          </a:xfrm>
-          <a:prstGeom prst="roundRect">
-            <a:avLst>
-              <a:gd name="adj" fmla="val 12000"/>
-            </a:avLst>
-          </a:prstGeom>
-          <a:solidFill>
-            <a:srgbClr val="ECF1F7"/>
-          </a:solidFill>
-          <a:ln>
-            <a:noFill/>
-          </a:ln>
-          <a:effectLst/>
-        </p:spPr>
-        <p:style>
-          <a:lnRef idx="1">
-            <a:schemeClr val="accent1"/>
-          </a:lnRef>
-          <a:fillRef idx="3">
-            <a:schemeClr val="accent1"/>
-          </a:fillRef>
-          <a:effectRef idx="0">
-            <a:schemeClr val="accent1"/>
-          </a:effectRef>
-          <a:fontRef idx="minor">
-            <a:schemeClr val="lt1"/>
-          </a:fontRef>
-        </p:style>
-        <p:txBody>
-          <a:bodyPr rtlCol="0" anchor="ctr"/>
-          <a:lstStyle/>
-          <a:p>
-            <a:pPr algn="ctr"/>
-          </a:p>
-        </p:txBody>
-      </p:sp>
-      <p:sp>
-        <p:nvSpPr>
-          <p:cNvPr id="11" name="TextBox 10"/>
-          <p:cNvSpPr txBox="1"/>
-          <p:nvPr/>
-        </p:nvSpPr>
-        <p:spPr>
-          <a:xfrm>
-            <a:off x="841248" y="3483864"/>
-            <a:ext cx="3831336" cy="283464"/>
-          </a:xfrm>
-          <a:prstGeom prst="rect">
-            <a:avLst/>
-          </a:prstGeom>
-          <a:noFill/>
-          <a:effectLst/>
-        </p:spPr>
-        <p:txBody>
-          <a:bodyPr wrap="none" lIns="0" rIns="0" tIns="0" bIns="0">
-            <a:spAutoFit/>
-          </a:bodyPr>
-          <a:lstStyle/>
-          <a:p>
-            <a:pPr>
-              <a:spcAft>
-                <a:spcPts val="700"/>
-              </a:spcAft>
-              <a:defRPr sz="1400" b="1">
-                <a:solidFill>
-                  <a:srgbClr val="142B46"/>
-                </a:solidFill>
-                <a:latin typeface="Noto Sans CJK SC"/>
-              </a:defRPr>
-            </a:pPr>
-            <a:r>
-              <a:t>P5b｜预测融合何时有害</a:t>
-            </a:r>
-          </a:p>
-        </p:txBody>
-      </p:sp>
-      <p:sp>
-        <p:nvSpPr>
-          <p:cNvPr id="12" name="TextBox 11"/>
-          <p:cNvSpPr txBox="1"/>
-          <p:nvPr/>
-        </p:nvSpPr>
-        <p:spPr>
-          <a:xfrm>
-            <a:off x="841248" y="3904487"/>
-            <a:ext cx="3831336" cy="228600"/>
-          </a:xfrm>
-          <a:prstGeom prst="rect">
-            <a:avLst/>
-          </a:prstGeom>
-          <a:noFill/>
-          <a:effectLst/>
-        </p:spPr>
-        <p:txBody>
-          <a:bodyPr wrap="none" lIns="0" rIns="0" tIns="0" bIns="0">
-            <a:spAutoFit/>
-          </a:bodyPr>
-          <a:lstStyle/>
-          <a:p>
-            <a:pPr>
-              <a:spcAft>
-                <a:spcPts val="700"/>
-              </a:spcAft>
-              <a:defRPr sz="1000" b="0">
-                <a:solidFill>
-                  <a:srgbClr val="62748A"/>
-                </a:solidFill>
-                <a:latin typeface="Noto Sans CJK SC"/>
-              </a:defRPr>
-            </a:pPr>
-            <a:r>
-              <a:t>按轨迹分组的折外预测 AUC = 0.52，接近随机</a:t>
-            </a:r>
-          </a:p>
-        </p:txBody>
-      </p:sp>
-      <p:sp>
-        <p:nvSpPr>
-          <p:cNvPr id="13" name="Rounded Rectangle 12"/>
-          <p:cNvSpPr/>
-          <p:nvPr/>
-        </p:nvSpPr>
-        <p:spPr>
-          <a:xfrm>
-            <a:off x="685800" y="4407408"/>
-            <a:ext cx="4142232" cy="813816"/>
-          </a:xfrm>
-          <a:prstGeom prst="roundRect">
-            <a:avLst>
-              <a:gd name="adj" fmla="val 12000"/>
-            </a:avLst>
-          </a:prstGeom>
-          <a:solidFill>
-            <a:srgbClr val="ECF1F7"/>
-          </a:solidFill>
-          <a:ln>
-            <a:noFill/>
-          </a:ln>
-          <a:effectLst/>
-        </p:spPr>
-        <p:style>
-          <a:lnRef idx="1">
-            <a:schemeClr val="accent1"/>
-          </a:lnRef>
-          <a:fillRef idx="3">
-            <a:schemeClr val="accent1"/>
-          </a:fillRef>
-          <a:effectRef idx="0">
-            <a:schemeClr val="accent1"/>
-          </a:effectRef>
-          <a:fontRef idx="minor">
-            <a:schemeClr val="lt1"/>
-          </a:fontRef>
-        </p:style>
-        <p:txBody>
-          <a:bodyPr rtlCol="0" anchor="ctr"/>
-          <a:lstStyle/>
-          <a:p>
-            <a:pPr algn="ctr"/>
-          </a:p>
-        </p:txBody>
-      </p:sp>
-      <p:sp>
-        <p:nvSpPr>
-          <p:cNvPr id="14" name="TextBox 13"/>
-          <p:cNvSpPr txBox="1"/>
-          <p:nvPr/>
-        </p:nvSpPr>
-        <p:spPr>
-          <a:xfrm>
-            <a:off x="841248" y="4517136"/>
-            <a:ext cx="3831336" cy="283464"/>
-          </a:xfrm>
-          <a:prstGeom prst="rect">
-            <a:avLst/>
-          </a:prstGeom>
-          <a:noFill/>
-          <a:effectLst/>
-        </p:spPr>
-        <p:txBody>
-          <a:bodyPr wrap="none" lIns="0" rIns="0" tIns="0" bIns="0">
-            <a:spAutoFit/>
-          </a:bodyPr>
-          <a:lstStyle/>
-          <a:p>
-            <a:pPr>
-              <a:spcAft>
-                <a:spcPts val="700"/>
-              </a:spcAft>
-              <a:defRPr sz="1400" b="1">
-                <a:solidFill>
-                  <a:srgbClr val="142B46"/>
-                </a:solidFill>
-                <a:latin typeface="Noto Sans CJK SC"/>
-              </a:defRPr>
-            </a:pPr>
-            <a:r>
-              <a:t>P5c｜学习连续抑制强度</a:t>
-            </a:r>
-          </a:p>
-        </p:txBody>
-      </p:sp>
-      <p:sp>
-        <p:nvSpPr>
-          <p:cNvPr id="15" name="TextBox 14"/>
-          <p:cNvSpPr txBox="1"/>
-          <p:nvPr/>
-        </p:nvSpPr>
-        <p:spPr>
-          <a:xfrm>
-            <a:off x="841248" y="4937760"/>
-            <a:ext cx="3831336" cy="228600"/>
-          </a:xfrm>
-          <a:prstGeom prst="rect">
-            <a:avLst/>
-          </a:prstGeom>
-          <a:noFill/>
-          <a:effectLst/>
-        </p:spPr>
-        <p:txBody>
-          <a:bodyPr wrap="none" lIns="0" rIns="0" tIns="0" bIns="0">
-            <a:spAutoFit/>
-          </a:bodyPr>
-          <a:lstStyle/>
-          <a:p>
-            <a:pPr>
-              <a:spcAft>
-                <a:spcPts val="700"/>
-              </a:spcAft>
-              <a:defRPr sz="1000" b="0">
-                <a:solidFill>
-                  <a:srgbClr val="62748A"/>
-                </a:solidFill>
-                <a:latin typeface="Noto Sans CJK SC"/>
-              </a:defRPr>
-            </a:pPr>
-            <a:r>
-              <a:t>平均抑制强度约 0.027，几乎退回原 κ 融合</a:t>
-            </a:r>
-          </a:p>
-        </p:txBody>
-      </p:sp>
-      <p:sp>
-        <p:nvSpPr>
-          <p:cNvPr id="16" name="TextBox 15"/>
-          <p:cNvSpPr txBox="1"/>
-          <p:nvPr/>
-        </p:nvSpPr>
-        <p:spPr>
-          <a:xfrm>
-            <a:off x="5230368" y="2350008"/>
-            <a:ext cx="6281928" cy="310896"/>
+            <a:off x="859536" y="2423160"/>
+            <a:ext cx="10424160" cy="283464"/>
           </a:xfrm>
           <a:prstGeom prst="rect">
             <a:avLst/>
@@ -4173,21 +3856,21 @@
               </a:defRPr>
             </a:pPr>
             <a:r>
-              <a:t>同批次内比较：use_cm，越高越好</a:t>
-            </a:r>
-          </a:p>
-        </p:txBody>
-      </p:sp>
-      <p:sp>
-        <p:nvSpPr>
-          <p:cNvPr id="17" name="TextBox 16"/>
+              <a:t>原方法：根据两种预测的置信度，决定各自占多大比重。</a:t>
+            </a:r>
+          </a:p>
+        </p:txBody>
+      </p:sp>
+      <p:sp>
+        <p:nvSpPr>
+          <p:cNvPr id="9" name="TextBox 8"/>
           <p:cNvSpPr txBox="1"/>
           <p:nvPr/>
         </p:nvSpPr>
         <p:spPr>
           <a:xfrm>
-            <a:off x="5230368" y="2743200"/>
-            <a:ext cx="6281928" cy="228600"/>
+            <a:off x="841248" y="3099816"/>
+            <a:ext cx="4846320" cy="292608"/>
           </a:xfrm>
           <a:prstGeom prst="rect">
             <a:avLst/>
@@ -4205,253 +3888,7 @@
               <a:spcAft>
                 <a:spcPts val="700"/>
               </a:spcAft>
-              <a:defRPr sz="1100" b="0">
-                <a:solidFill>
-                  <a:srgbClr val="62748A"/>
-                </a:solidFill>
-                <a:latin typeface="Noto Sans CJK SC"/>
-              </a:defRPr>
-            </a:pPr>
-            <a:r>
-              <a:t>每行独立比较；不同评估批次不做横向排名。</a:t>
-            </a:r>
-          </a:p>
-        </p:txBody>
-      </p:sp>
-      <p:sp>
-        <p:nvSpPr>
-          <p:cNvPr id="18" name="Rounded Rectangle 17"/>
-          <p:cNvSpPr/>
-          <p:nvPr/>
-        </p:nvSpPr>
-        <p:spPr>
-          <a:xfrm>
-            <a:off x="5230368" y="3154680"/>
-            <a:ext cx="6281928" cy="411480"/>
-          </a:xfrm>
-          <a:prstGeom prst="roundRect">
-            <a:avLst>
-              <a:gd name="adj" fmla="val 12000"/>
-            </a:avLst>
-          </a:prstGeom>
-          <a:solidFill>
-            <a:srgbClr val="ECF1F7"/>
-          </a:solidFill>
-          <a:ln>
-            <a:noFill/>
-          </a:ln>
-          <a:effectLst/>
-        </p:spPr>
-        <p:style>
-          <a:lnRef idx="1">
-            <a:schemeClr val="accent1"/>
-          </a:lnRef>
-          <a:fillRef idx="3">
-            <a:schemeClr val="accent1"/>
-          </a:fillRef>
-          <a:effectRef idx="0">
-            <a:schemeClr val="accent1"/>
-          </a:effectRef>
-          <a:fontRef idx="minor">
-            <a:schemeClr val="lt1"/>
-          </a:fontRef>
-        </p:style>
-        <p:txBody>
-          <a:bodyPr rtlCol="0" anchor="ctr"/>
-          <a:lstStyle/>
-          <a:p>
-            <a:pPr algn="ctr"/>
-          </a:p>
-        </p:txBody>
-      </p:sp>
-      <p:sp>
-        <p:nvSpPr>
-          <p:cNvPr id="19" name="TextBox 18"/>
-          <p:cNvSpPr txBox="1"/>
-          <p:nvPr/>
-        </p:nvSpPr>
-        <p:spPr>
-          <a:xfrm>
-            <a:off x="5349240" y="3264408"/>
-            <a:ext cx="2468880" cy="228600"/>
-          </a:xfrm>
-          <a:prstGeom prst="rect">
-            <a:avLst/>
-          </a:prstGeom>
-          <a:noFill/>
-          <a:effectLst/>
-        </p:spPr>
-        <p:txBody>
-          <a:bodyPr wrap="none" lIns="0" rIns="0" tIns="0" bIns="0">
-            <a:spAutoFit/>
-          </a:bodyPr>
-          <a:lstStyle/>
-          <a:p>
-            <a:pPr>
-              <a:spcAft>
-                <a:spcPts val="700"/>
-              </a:spcAft>
-              <a:defRPr sz="1100" b="1">
-                <a:solidFill>
-                  <a:srgbClr val="62748A"/>
-                </a:solidFill>
-                <a:latin typeface="Noto Sans CJK SC"/>
-              </a:defRPr>
-            </a:pPr>
-            <a:r>
-              <a:t>评估批次</a:t>
-            </a:r>
-          </a:p>
-        </p:txBody>
-      </p:sp>
-      <p:sp>
-        <p:nvSpPr>
-          <p:cNvPr id="20" name="TextBox 19"/>
-          <p:cNvSpPr txBox="1"/>
-          <p:nvPr/>
-        </p:nvSpPr>
-        <p:spPr>
-          <a:xfrm>
-            <a:off x="7991856" y="3255264"/>
-            <a:ext cx="1078992" cy="228600"/>
-          </a:xfrm>
-          <a:prstGeom prst="rect">
-            <a:avLst/>
-          </a:prstGeom>
-          <a:noFill/>
-          <a:effectLst/>
-        </p:spPr>
-        <p:txBody>
-          <a:bodyPr wrap="none" lIns="0" rIns="0" tIns="0" bIns="0">
-            <a:spAutoFit/>
-          </a:bodyPr>
-          <a:lstStyle/>
-          <a:p>
-            <a:pPr algn="ctr">
-              <a:spcAft>
-                <a:spcPts val="700"/>
-              </a:spcAft>
-              <a:defRPr sz="1100" b="1">
-                <a:solidFill>
-                  <a:srgbClr val="62748A"/>
-                </a:solidFill>
-                <a:latin typeface="Noto Sans CJK SC"/>
-              </a:defRPr>
-            </a:pPr>
-            <a:r>
-              <a:t>κ 基线</a:t>
-            </a:r>
-          </a:p>
-        </p:txBody>
-      </p:sp>
-      <p:sp>
-        <p:nvSpPr>
-          <p:cNvPr id="21" name="TextBox 20"/>
-          <p:cNvSpPr txBox="1"/>
-          <p:nvPr/>
-        </p:nvSpPr>
-        <p:spPr>
-          <a:xfrm>
-            <a:off x="9162288" y="3255264"/>
-            <a:ext cx="1078992" cy="228600"/>
-          </a:xfrm>
-          <a:prstGeom prst="rect">
-            <a:avLst/>
-          </a:prstGeom>
-          <a:noFill/>
-          <a:effectLst/>
-        </p:spPr>
-        <p:txBody>
-          <a:bodyPr wrap="none" lIns="0" rIns="0" tIns="0" bIns="0">
-            <a:spAutoFit/>
-          </a:bodyPr>
-          <a:lstStyle/>
-          <a:p>
-            <a:pPr algn="ctr">
-              <a:spcAft>
-                <a:spcPts val="700"/>
-              </a:spcAft>
-              <a:defRPr sz="1100" b="1">
-                <a:solidFill>
-                  <a:srgbClr val="62748A"/>
-                </a:solidFill>
-                <a:latin typeface="Noto Sans CJK SC"/>
-              </a:defRPr>
-            </a:pPr>
-            <a:r>
-              <a:t>门控策略</a:t>
-            </a:r>
-          </a:p>
-        </p:txBody>
-      </p:sp>
-      <p:sp>
-        <p:nvSpPr>
-          <p:cNvPr id="22" name="TextBox 21"/>
-          <p:cNvSpPr txBox="1"/>
-          <p:nvPr/>
-        </p:nvSpPr>
-        <p:spPr>
-          <a:xfrm>
-            <a:off x="10332720" y="3255264"/>
-            <a:ext cx="1179576" cy="228600"/>
-          </a:xfrm>
-          <a:prstGeom prst="rect">
-            <a:avLst/>
-          </a:prstGeom>
-          <a:noFill/>
-          <a:effectLst/>
-        </p:spPr>
-        <p:txBody>
-          <a:bodyPr wrap="none" lIns="0" rIns="0" tIns="0" bIns="0">
-            <a:spAutoFit/>
-          </a:bodyPr>
-          <a:lstStyle/>
-          <a:p>
-            <a:pPr algn="ctr">
-              <a:spcAft>
-                <a:spcPts val="700"/>
-              </a:spcAft>
-              <a:defRPr sz="1100" b="1">
-                <a:solidFill>
-                  <a:srgbClr val="62748A"/>
-                </a:solidFill>
-                <a:latin typeface="Noto Sans CJK SC"/>
-              </a:defRPr>
-            </a:pPr>
-            <a:r>
-              <a:t>离线参考*</a:t>
-            </a:r>
-          </a:p>
-        </p:txBody>
-      </p:sp>
-      <p:sp>
-        <p:nvSpPr>
-          <p:cNvPr id="23" name="TextBox 22"/>
-          <p:cNvSpPr txBox="1"/>
-          <p:nvPr/>
-        </p:nvSpPr>
-        <p:spPr>
-          <a:xfrm>
-            <a:off x="5276088" y="3767328"/>
-            <a:ext cx="2697480" cy="274320"/>
-          </a:xfrm>
-          <a:prstGeom prst="rect">
-            <a:avLst/>
-          </a:prstGeom>
-          <a:noFill/>
-          <a:effectLst/>
-        </p:spPr>
-        <p:txBody>
-          <a:bodyPr wrap="none" lIns="0" rIns="0" tIns="0" bIns="0">
-            <a:spAutoFit/>
-          </a:bodyPr>
-          <a:lstStyle/>
-          <a:p>
-            <a:pPr>
-              <a:spcAft>
-                <a:spcPts val="700"/>
-              </a:spcAft>
-              <a:defRPr sz="1100" b="0">
+              <a:defRPr sz="1600" b="1">
                 <a:solidFill>
                   <a:srgbClr val="142B46"/>
                 </a:solidFill>
@@ -4459,21 +3896,21 @@
               </a:defRPr>
             </a:pPr>
             <a:r>
-              <a:t>P5b｜ADE 反事实</a:t>
-            </a:r>
-          </a:p>
-        </p:txBody>
-      </p:sp>
-      <p:sp>
-        <p:nvSpPr>
-          <p:cNvPr id="24" name="TextBox 23"/>
+              <a:t>我们尝试了什么？</a:t>
+            </a:r>
+          </a:p>
+        </p:txBody>
+      </p:sp>
+      <p:sp>
+        <p:nvSpPr>
+          <p:cNvPr id="10" name="TextBox 9"/>
           <p:cNvSpPr txBox="1"/>
           <p:nvPr/>
         </p:nvSpPr>
         <p:spPr>
           <a:xfrm>
-            <a:off x="7991856" y="3767328"/>
-            <a:ext cx="1078992" cy="283464"/>
+            <a:off x="6217920" y="3099816"/>
+            <a:ext cx="4937760" cy="292608"/>
           </a:xfrm>
           <a:prstGeom prst="rect">
             <a:avLst/>
@@ -4487,51 +3924,11 @@
           </a:bodyPr>
           <a:lstStyle/>
           <a:p>
-            <a:pPr algn="ctr">
+            <a:pPr>
               <a:spcAft>
                 <a:spcPts val="700"/>
               </a:spcAft>
-              <a:defRPr sz="1400" b="1">
-                <a:solidFill>
-                  <a:srgbClr val="148D91"/>
-                </a:solidFill>
-                <a:latin typeface="Noto Sans CJK SC"/>
-              </a:defRPr>
-            </a:pPr>
-            <a:r>
-              <a:t>+2.62</a:t>
-            </a:r>
-          </a:p>
-        </p:txBody>
-      </p:sp>
-      <p:sp>
-        <p:nvSpPr>
-          <p:cNvPr id="25" name="TextBox 24"/>
-          <p:cNvSpPr txBox="1"/>
-          <p:nvPr/>
-        </p:nvSpPr>
-        <p:spPr>
-          <a:xfrm>
-            <a:off x="9162288" y="3767328"/>
-            <a:ext cx="1078992" cy="283464"/>
-          </a:xfrm>
-          <a:prstGeom prst="rect">
-            <a:avLst/>
-          </a:prstGeom>
-          <a:noFill/>
-          <a:effectLst/>
-        </p:spPr>
-        <p:txBody>
-          <a:bodyPr wrap="none" lIns="0" rIns="0" tIns="0" bIns="0">
-            <a:spAutoFit/>
-          </a:bodyPr>
-          <a:lstStyle/>
-          <a:p>
-            <a:pPr algn="ctr">
-              <a:spcAft>
-                <a:spcPts val="700"/>
-              </a:spcAft>
-              <a:defRPr sz="1400" b="0">
+              <a:defRPr sz="1600" b="1">
                 <a:solidFill>
                   <a:srgbClr val="142B46"/>
                 </a:solidFill>
@@ -4539,66 +3936,26 @@
               </a:defRPr>
             </a:pPr>
             <a:r>
-              <a:t>+2.62</a:t>
-            </a:r>
-          </a:p>
-        </p:txBody>
-      </p:sp>
-      <p:sp>
-        <p:nvSpPr>
-          <p:cNvPr id="26" name="TextBox 25"/>
-          <p:cNvSpPr txBox="1"/>
-          <p:nvPr/>
-        </p:nvSpPr>
-        <p:spPr>
-          <a:xfrm>
-            <a:off x="10332720" y="3767328"/>
-            <a:ext cx="1179576" cy="283464"/>
-          </a:xfrm>
-          <a:prstGeom prst="rect">
-            <a:avLst/>
-          </a:prstGeom>
-          <a:noFill/>
-          <a:effectLst/>
-        </p:spPr>
-        <p:txBody>
-          <a:bodyPr wrap="none" lIns="0" rIns="0" tIns="0" bIns="0">
-            <a:spAutoFit/>
-          </a:bodyPr>
-          <a:lstStyle/>
-          <a:p>
-            <a:pPr algn="ctr">
-              <a:spcAft>
-                <a:spcPts val="700"/>
-              </a:spcAft>
-              <a:defRPr sz="1400" b="0">
-                <a:solidFill>
-                  <a:srgbClr val="142B46"/>
-                </a:solidFill>
-                <a:latin typeface="Noto Sans CJK SC"/>
-              </a:defRPr>
-            </a:pPr>
-            <a:r>
-              <a:t>+3.80</a:t>
+              <a:t>结果怎么样？</a:t>
             </a:r>
           </a:p>
         </p:txBody>
       </p:sp>
       <p:cxnSp>
         <p:nvCxnSpPr>
-          <p:cNvPr id="27" name="Connector 26"/>
+          <p:cNvPr id="11" name="Connector 10"/>
           <p:cNvCxnSpPr/>
           <p:nvPr/>
         </p:nvCxnSpPr>
         <p:spPr>
           <a:xfrm>
-            <a:off x="5230368" y="4078224"/>
-            <a:ext cx="6281928" cy="0"/>
+            <a:off x="685800" y="3520440"/>
+            <a:ext cx="10826496" cy="0"/>
           </a:xfrm>
           <a:prstGeom prst="line">
             <a:avLst/>
           </a:prstGeom>
-          <a:ln w="8255">
+          <a:ln w="10160">
             <a:solidFill>
               <a:srgbClr val="DCE5EF"/>
             </a:solidFill>
@@ -4622,501 +3979,13 @@
       </p:cxnSp>
       <p:sp>
         <p:nvSpPr>
-          <p:cNvPr id="28" name="TextBox 27"/>
-          <p:cNvSpPr txBox="1"/>
-          <p:nvPr/>
-        </p:nvSpPr>
-        <p:spPr>
-          <a:xfrm>
-            <a:off x="5276088" y="4178808"/>
-            <a:ext cx="2697480" cy="274320"/>
-          </a:xfrm>
-          <a:prstGeom prst="rect">
-            <a:avLst/>
-          </a:prstGeom>
-          <a:noFill/>
-          <a:effectLst/>
-        </p:spPr>
-        <p:txBody>
-          <a:bodyPr wrap="none" lIns="0" rIns="0" tIns="0" bIns="0">
-            <a:spAutoFit/>
-          </a:bodyPr>
-          <a:lstStyle/>
-          <a:p>
-            <a:pPr>
-              <a:spcAft>
-                <a:spcPts val="700"/>
-              </a:spcAft>
-              <a:defRPr sz="1100" b="0">
-                <a:solidFill>
-                  <a:srgbClr val="142B46"/>
-                </a:solidFill>
-                <a:latin typeface="Noto Sans CJK SC"/>
-              </a:defRPr>
-            </a:pPr>
-            <a:r>
-              <a:t>P5c｜rollout</a:t>
-            </a:r>
-          </a:p>
-        </p:txBody>
-      </p:sp>
-      <p:sp>
-        <p:nvSpPr>
-          <p:cNvPr id="29" name="TextBox 28"/>
-          <p:cNvSpPr txBox="1"/>
-          <p:nvPr/>
-        </p:nvSpPr>
-        <p:spPr>
-          <a:xfrm>
-            <a:off x="7991856" y="4178808"/>
-            <a:ext cx="1078992" cy="283464"/>
-          </a:xfrm>
-          <a:prstGeom prst="rect">
-            <a:avLst/>
-          </a:prstGeom>
-          <a:noFill/>
-          <a:effectLst/>
-        </p:spPr>
-        <p:txBody>
-          <a:bodyPr wrap="none" lIns="0" rIns="0" tIns="0" bIns="0">
-            <a:spAutoFit/>
-          </a:bodyPr>
-          <a:lstStyle/>
-          <a:p>
-            <a:pPr algn="ctr">
-              <a:spcAft>
-                <a:spcPts val="700"/>
-              </a:spcAft>
-              <a:defRPr sz="1400" b="1">
-                <a:solidFill>
-                  <a:srgbClr val="148D91"/>
-                </a:solidFill>
-                <a:latin typeface="Noto Sans CJK SC"/>
-              </a:defRPr>
-            </a:pPr>
-            <a:r>
-              <a:t>+2.69</a:t>
-            </a:r>
-          </a:p>
-        </p:txBody>
-      </p:sp>
-      <p:sp>
-        <p:nvSpPr>
-          <p:cNvPr id="30" name="TextBox 29"/>
-          <p:cNvSpPr txBox="1"/>
-          <p:nvPr/>
-        </p:nvSpPr>
-        <p:spPr>
-          <a:xfrm>
-            <a:off x="9162288" y="4178808"/>
-            <a:ext cx="1078992" cy="283464"/>
-          </a:xfrm>
-          <a:prstGeom prst="rect">
-            <a:avLst/>
-          </a:prstGeom>
-          <a:noFill/>
-          <a:effectLst/>
-        </p:spPr>
-        <p:txBody>
-          <a:bodyPr wrap="none" lIns="0" rIns="0" tIns="0" bIns="0">
-            <a:spAutoFit/>
-          </a:bodyPr>
-          <a:lstStyle/>
-          <a:p>
-            <a:pPr algn="ctr">
-              <a:spcAft>
-                <a:spcPts val="700"/>
-              </a:spcAft>
-              <a:defRPr sz="1400" b="0">
-                <a:solidFill>
-                  <a:srgbClr val="142B46"/>
-                </a:solidFill>
-                <a:latin typeface="Noto Sans CJK SC"/>
-              </a:defRPr>
-            </a:pPr>
-            <a:r>
-              <a:t>+2.69</a:t>
-            </a:r>
-          </a:p>
-        </p:txBody>
-      </p:sp>
-      <p:sp>
-        <p:nvSpPr>
-          <p:cNvPr id="31" name="TextBox 30"/>
-          <p:cNvSpPr txBox="1"/>
-          <p:nvPr/>
-        </p:nvSpPr>
-        <p:spPr>
-          <a:xfrm>
-            <a:off x="10332720" y="4178808"/>
-            <a:ext cx="1179576" cy="283464"/>
-          </a:xfrm>
-          <a:prstGeom prst="rect">
-            <a:avLst/>
-          </a:prstGeom>
-          <a:noFill/>
-          <a:effectLst/>
-        </p:spPr>
-        <p:txBody>
-          <a:bodyPr wrap="none" lIns="0" rIns="0" tIns="0" bIns="0">
-            <a:spAutoFit/>
-          </a:bodyPr>
-          <a:lstStyle/>
-          <a:p>
-            <a:pPr algn="ctr">
-              <a:spcAft>
-                <a:spcPts val="700"/>
-              </a:spcAft>
-              <a:defRPr sz="1400" b="0">
-                <a:solidFill>
-                  <a:srgbClr val="142B46"/>
-                </a:solidFill>
-                <a:latin typeface="Noto Sans CJK SC"/>
-              </a:defRPr>
-            </a:pPr>
-            <a:r>
-              <a:t>+3.59</a:t>
-            </a:r>
-          </a:p>
-        </p:txBody>
-      </p:sp>
-      <p:cxnSp>
-        <p:nvCxnSpPr>
-          <p:cNvPr id="32" name="Connector 31"/>
-          <p:cNvCxnSpPr/>
-          <p:nvPr/>
-        </p:nvCxnSpPr>
-        <p:spPr>
-          <a:xfrm>
-            <a:off x="5230368" y="4489704"/>
-            <a:ext cx="6281928" cy="0"/>
-          </a:xfrm>
-          <a:prstGeom prst="line">
-            <a:avLst/>
-          </a:prstGeom>
-          <a:ln w="8255">
-            <a:solidFill>
-              <a:srgbClr val="DCE5EF"/>
-            </a:solidFill>
-          </a:ln>
-          <a:effectLst/>
-        </p:spPr>
-        <p:style>
-          <a:lnRef idx="2">
-            <a:schemeClr val="accent1"/>
-          </a:lnRef>
-          <a:fillRef idx="0">
-            <a:schemeClr val="accent1"/>
-          </a:fillRef>
-          <a:effectRef idx="0">
-            <a:schemeClr val="accent1"/>
-          </a:effectRef>
-          <a:fontRef idx="minor">
-            <a:schemeClr val="tx1"/>
-          </a:fontRef>
-        </p:style>
-      </p:cxnSp>
-      <p:sp>
-        <p:nvSpPr>
-          <p:cNvPr id="33" name="TextBox 32"/>
-          <p:cNvSpPr txBox="1"/>
-          <p:nvPr/>
-        </p:nvSpPr>
-        <p:spPr>
-          <a:xfrm>
-            <a:off x="5276088" y="4590288"/>
-            <a:ext cx="2697480" cy="274320"/>
-          </a:xfrm>
-          <a:prstGeom prst="rect">
-            <a:avLst/>
-          </a:prstGeom>
-          <a:noFill/>
-          <a:effectLst/>
-        </p:spPr>
-        <p:txBody>
-          <a:bodyPr wrap="none" lIns="0" rIns="0" tIns="0" bIns="0">
-            <a:spAutoFit/>
-          </a:bodyPr>
-          <a:lstStyle/>
-          <a:p>
-            <a:pPr>
-              <a:spcAft>
-                <a:spcPts val="700"/>
-              </a:spcAft>
-              <a:defRPr sz="1100" b="0">
-                <a:solidFill>
-                  <a:srgbClr val="142B46"/>
-                </a:solidFill>
-                <a:latin typeface="Noto Sans CJK SC"/>
-              </a:defRPr>
-            </a:pPr>
-            <a:r>
-              <a:t>固定分歧门控｜rollout</a:t>
-            </a:r>
-          </a:p>
-        </p:txBody>
-      </p:sp>
-      <p:sp>
-        <p:nvSpPr>
-          <p:cNvPr id="34" name="TextBox 33"/>
-          <p:cNvSpPr txBox="1"/>
-          <p:nvPr/>
-        </p:nvSpPr>
-        <p:spPr>
-          <a:xfrm>
-            <a:off x="7991856" y="4590288"/>
-            <a:ext cx="1078992" cy="283464"/>
-          </a:xfrm>
-          <a:prstGeom prst="rect">
-            <a:avLst/>
-          </a:prstGeom>
-          <a:noFill/>
-          <a:effectLst/>
-        </p:spPr>
-        <p:txBody>
-          <a:bodyPr wrap="none" lIns="0" rIns="0" tIns="0" bIns="0">
-            <a:spAutoFit/>
-          </a:bodyPr>
-          <a:lstStyle/>
-          <a:p>
-            <a:pPr algn="ctr">
-              <a:spcAft>
-                <a:spcPts val="700"/>
-              </a:spcAft>
-              <a:defRPr sz="1400" b="1">
-                <a:solidFill>
-                  <a:srgbClr val="148D91"/>
-                </a:solidFill>
-                <a:latin typeface="Noto Sans CJK SC"/>
-              </a:defRPr>
-            </a:pPr>
-            <a:r>
-              <a:t>+2.80</a:t>
-            </a:r>
-          </a:p>
-        </p:txBody>
-      </p:sp>
-      <p:sp>
-        <p:nvSpPr>
-          <p:cNvPr id="35" name="TextBox 34"/>
-          <p:cNvSpPr txBox="1"/>
-          <p:nvPr/>
-        </p:nvSpPr>
-        <p:spPr>
-          <a:xfrm>
-            <a:off x="9162288" y="4590288"/>
-            <a:ext cx="1078992" cy="283464"/>
-          </a:xfrm>
-          <a:prstGeom prst="rect">
-            <a:avLst/>
-          </a:prstGeom>
-          <a:noFill/>
-          <a:effectLst/>
-        </p:spPr>
-        <p:txBody>
-          <a:bodyPr wrap="none" lIns="0" rIns="0" tIns="0" bIns="0">
-            <a:spAutoFit/>
-          </a:bodyPr>
-          <a:lstStyle/>
-          <a:p>
-            <a:pPr algn="ctr">
-              <a:spcAft>
-                <a:spcPts val="700"/>
-              </a:spcAft>
-              <a:defRPr sz="1400" b="0">
-                <a:solidFill>
-                  <a:srgbClr val="142B46"/>
-                </a:solidFill>
-                <a:latin typeface="Noto Sans CJK SC"/>
-              </a:defRPr>
-            </a:pPr>
-            <a:r>
-              <a:t>+2.24</a:t>
-            </a:r>
-          </a:p>
-        </p:txBody>
-      </p:sp>
-      <p:sp>
-        <p:nvSpPr>
-          <p:cNvPr id="36" name="TextBox 35"/>
-          <p:cNvSpPr txBox="1"/>
-          <p:nvPr/>
-        </p:nvSpPr>
-        <p:spPr>
-          <a:xfrm>
-            <a:off x="10332720" y="4590288"/>
-            <a:ext cx="1179576" cy="283464"/>
-          </a:xfrm>
-          <a:prstGeom prst="rect">
-            <a:avLst/>
-          </a:prstGeom>
-          <a:noFill/>
-          <a:effectLst/>
-        </p:spPr>
-        <p:txBody>
-          <a:bodyPr wrap="none" lIns="0" rIns="0" tIns="0" bIns="0">
-            <a:spAutoFit/>
-          </a:bodyPr>
-          <a:lstStyle/>
-          <a:p>
-            <a:pPr algn="ctr">
-              <a:spcAft>
-                <a:spcPts val="700"/>
-              </a:spcAft>
-              <a:defRPr sz="1400" b="0">
-                <a:solidFill>
-                  <a:srgbClr val="142B46"/>
-                </a:solidFill>
-                <a:latin typeface="Noto Sans CJK SC"/>
-              </a:defRPr>
-            </a:pPr>
-            <a:r>
-              <a:t>+3.16</a:t>
-            </a:r>
-          </a:p>
-        </p:txBody>
-      </p:sp>
-      <p:cxnSp>
-        <p:nvCxnSpPr>
-          <p:cNvPr id="37" name="Connector 36"/>
-          <p:cNvCxnSpPr/>
-          <p:nvPr/>
-        </p:nvCxnSpPr>
-        <p:spPr>
-          <a:xfrm>
-            <a:off x="5230368" y="4901184"/>
-            <a:ext cx="6281928" cy="0"/>
-          </a:xfrm>
-          <a:prstGeom prst="line">
-            <a:avLst/>
-          </a:prstGeom>
-          <a:ln w="8255">
-            <a:solidFill>
-              <a:srgbClr val="DCE5EF"/>
-            </a:solidFill>
-          </a:ln>
-          <a:effectLst/>
-        </p:spPr>
-        <p:style>
-          <a:lnRef idx="2">
-            <a:schemeClr val="accent1"/>
-          </a:lnRef>
-          <a:fillRef idx="0">
-            <a:schemeClr val="accent1"/>
-          </a:fillRef>
-          <a:effectRef idx="0">
-            <a:schemeClr val="accent1"/>
-          </a:effectRef>
-          <a:fontRef idx="minor">
-            <a:schemeClr val="tx1"/>
-          </a:fontRef>
-        </p:style>
-      </p:cxnSp>
-      <p:sp>
-        <p:nvSpPr>
-          <p:cNvPr id="38" name="TextBox 37"/>
-          <p:cNvSpPr txBox="1"/>
-          <p:nvPr/>
-        </p:nvSpPr>
-        <p:spPr>
-          <a:xfrm>
-            <a:off x="5230368" y="5175504"/>
-            <a:ext cx="6281928" cy="484632"/>
-          </a:xfrm>
-          <a:prstGeom prst="rect">
-            <a:avLst/>
-          </a:prstGeom>
-          <a:noFill/>
-          <a:effectLst/>
-        </p:spPr>
-        <p:txBody>
-          <a:bodyPr wrap="none" lIns="0" rIns="0" tIns="0" bIns="0">
-            <a:spAutoFit/>
-          </a:bodyPr>
-          <a:lstStyle/>
-          <a:p>
-            <a:pPr>
-              <a:spcAft>
-                <a:spcPts val="700"/>
-              </a:spcAft>
-              <a:defRPr sz="1000" b="0">
-                <a:solidFill>
-                  <a:srgbClr val="62748A"/>
-                </a:solidFill>
-                <a:latin typeface="Noto Sans CJK SC"/>
-              </a:defRPr>
-            </a:pPr>
-            <a:r>
-              <a:t>* 依次为：真实害益择优、代理最优抑制、GT 误差门控。</a:t>
-            </a:r>
-          </a:p>
-          <a:p>
-            <a:pPr>
-              <a:spcAft>
-                <a:spcPts val="700"/>
-              </a:spcAft>
-              <a:defRPr sz="1000" b="0">
-                <a:solidFill>
-                  <a:srgbClr val="62748A"/>
-                </a:solidFill>
-                <a:latin typeface="Noto Sans CJK SC"/>
-              </a:defRPr>
-            </a:pPr>
-            <a:r>
-              <a:t>这些离线参考使用额外信息，不能直接部署。</a:t>
-            </a:r>
-          </a:p>
-        </p:txBody>
-      </p:sp>
-      <p:sp>
-        <p:nvSpPr>
-          <p:cNvPr id="39" name="TextBox 38"/>
-          <p:cNvSpPr txBox="1"/>
-          <p:nvPr/>
-        </p:nvSpPr>
-        <p:spPr>
-          <a:xfrm>
-            <a:off x="685800" y="5797296"/>
-            <a:ext cx="10826496" cy="256032"/>
-          </a:xfrm>
-          <a:prstGeom prst="rect">
-            <a:avLst/>
-          </a:prstGeom>
-          <a:noFill/>
-          <a:effectLst/>
-        </p:spPr>
-        <p:txBody>
-          <a:bodyPr wrap="none" lIns="0" rIns="0" tIns="0" bIns="0">
-            <a:spAutoFit/>
-          </a:bodyPr>
-          <a:lstStyle/>
-          <a:p>
-            <a:pPr>
-              <a:spcAft>
-                <a:spcPts val="700"/>
-              </a:spcAft>
-              <a:defRPr sz="1000" b="0">
-                <a:solidFill>
-                  <a:srgbClr val="62748A"/>
-                </a:solidFill>
-                <a:latin typeface="Noto Sans CJK SC"/>
-              </a:defRPr>
-            </a:pPr>
-            <a:r>
-              <a:t>特征边界：P5b / P5c 含真实未来运动派生特征，属于离线探索，不能据此声称纯在线门控已验证。</a:t>
-            </a:r>
-          </a:p>
-        </p:txBody>
-      </p:sp>
-      <p:sp>
-        <p:nvSpPr>
-          <p:cNvPr id="40" name="Rounded Rectangle 39"/>
+          <p:cNvPr id="12" name="Rounded Rectangle 11"/>
           <p:cNvSpPr/>
           <p:nvPr/>
         </p:nvSpPr>
         <p:spPr>
           <a:xfrm>
-            <a:off x="685800" y="6190488"/>
+            <a:off x="685800" y="3675887"/>
             <a:ext cx="10826496" cy="411480"/>
           </a:xfrm>
           <a:prstGeom prst="roundRect">
@@ -5125,7 +3994,7 @@
             </a:avLst>
           </a:prstGeom>
           <a:solidFill>
-            <a:srgbClr val="E8F4F2"/>
+            <a:srgbClr val="F0F4F8"/>
           </a:solidFill>
           <a:ln>
             <a:noFill/>
@@ -5156,14 +4025,666 @@
       </p:sp>
       <p:sp>
         <p:nvSpPr>
-          <p:cNvPr id="41" name="TextBox 40"/>
+          <p:cNvPr id="13" name="TextBox 12"/>
           <p:cNvSpPr txBox="1"/>
           <p:nvPr/>
         </p:nvSpPr>
         <p:spPr>
           <a:xfrm>
-            <a:off x="859536" y="6263640"/>
-            <a:ext cx="10424160" cy="265176"/>
+            <a:off x="841248" y="3712463"/>
+            <a:ext cx="365760" cy="256032"/>
+          </a:xfrm>
+          <a:prstGeom prst="rect">
+            <a:avLst/>
+          </a:prstGeom>
+          <a:noFill/>
+          <a:effectLst/>
+        </p:spPr>
+        <p:txBody>
+          <a:bodyPr wrap="none" lIns="0" rIns="0" tIns="0" bIns="0">
+            <a:spAutoFit/>
+          </a:bodyPr>
+          <a:lstStyle/>
+          <a:p>
+            <a:pPr>
+              <a:spcAft>
+                <a:spcPts val="700"/>
+              </a:spcAft>
+              <a:defRPr sz="1100" b="1">
+                <a:solidFill>
+                  <a:srgbClr val="148D91"/>
+                </a:solidFill>
+                <a:latin typeface="Noto Sans CJK SC"/>
+              </a:defRPr>
+            </a:pPr>
+            <a:r>
+              <a:t>01</a:t>
+            </a:r>
+          </a:p>
+        </p:txBody>
+      </p:sp>
+      <p:sp>
+        <p:nvSpPr>
+          <p:cNvPr id="14" name="TextBox 13"/>
+          <p:cNvSpPr txBox="1"/>
+          <p:nvPr/>
+        </p:nvSpPr>
+        <p:spPr>
+          <a:xfrm>
+            <a:off x="1307592" y="3712463"/>
+            <a:ext cx="4681728" cy="283464"/>
+          </a:xfrm>
+          <a:prstGeom prst="rect">
+            <a:avLst/>
+          </a:prstGeom>
+          <a:noFill/>
+          <a:effectLst/>
+        </p:spPr>
+        <p:txBody>
+          <a:bodyPr wrap="none" lIns="0" rIns="0" tIns="0" bIns="0">
+            <a:spAutoFit/>
+          </a:bodyPr>
+          <a:lstStyle/>
+          <a:p>
+            <a:pPr>
+              <a:spcAft>
+                <a:spcPts val="700"/>
+              </a:spcAft>
+              <a:defRPr sz="1300" b="0">
+                <a:solidFill>
+                  <a:srgbClr val="142B46"/>
+                </a:solidFill>
+                <a:latin typeface="Noto Sans CJK SC"/>
+              </a:defRPr>
+            </a:pPr>
+            <a:r>
+              <a:t>看航点的权重占比，判断是否该少信它</a:t>
+            </a:r>
+          </a:p>
+        </p:txBody>
+      </p:sp>
+      <p:sp>
+        <p:nvSpPr>
+          <p:cNvPr id="15" name="TextBox 14"/>
+          <p:cNvSpPr txBox="1"/>
+          <p:nvPr/>
+        </p:nvSpPr>
+        <p:spPr>
+          <a:xfrm>
+            <a:off x="6217920" y="3712463"/>
+            <a:ext cx="5074920" cy="283464"/>
+          </a:xfrm>
+          <a:prstGeom prst="rect">
+            <a:avLst/>
+          </a:prstGeom>
+          <a:noFill/>
+          <a:effectLst/>
+        </p:spPr>
+        <p:txBody>
+          <a:bodyPr wrap="none" lIns="0" rIns="0" tIns="0" bIns="0">
+            <a:spAutoFit/>
+          </a:bodyPr>
+          <a:lstStyle/>
+          <a:p>
+            <a:pPr>
+              <a:spcAft>
+                <a:spcPts val="700"/>
+              </a:spcAft>
+              <a:defRPr sz="1300" b="0">
+                <a:solidFill>
+                  <a:srgbClr val="142B46"/>
+                </a:solidFill>
+                <a:latin typeface="Noto Sans CJK SC"/>
+              </a:defRPr>
+            </a:pPr>
+            <a:r>
+              <a:t>效果变好与变差的样本，权重占比接近。</a:t>
+            </a:r>
+          </a:p>
+        </p:txBody>
+      </p:sp>
+      <p:sp>
+        <p:nvSpPr>
+          <p:cNvPr id="16" name="TextBox 15"/>
+          <p:cNvSpPr txBox="1"/>
+          <p:nvPr/>
+        </p:nvSpPr>
+        <p:spPr>
+          <a:xfrm>
+            <a:off x="841248" y="4160520"/>
+            <a:ext cx="365760" cy="256032"/>
+          </a:xfrm>
+          <a:prstGeom prst="rect">
+            <a:avLst/>
+          </a:prstGeom>
+          <a:noFill/>
+          <a:effectLst/>
+        </p:spPr>
+        <p:txBody>
+          <a:bodyPr wrap="none" lIns="0" rIns="0" tIns="0" bIns="0">
+            <a:spAutoFit/>
+          </a:bodyPr>
+          <a:lstStyle/>
+          <a:p>
+            <a:pPr>
+              <a:spcAft>
+                <a:spcPts val="700"/>
+              </a:spcAft>
+              <a:defRPr sz="1100" b="1">
+                <a:solidFill>
+                  <a:srgbClr val="148D91"/>
+                </a:solidFill>
+                <a:latin typeface="Noto Sans CJK SC"/>
+              </a:defRPr>
+            </a:pPr>
+            <a:r>
+              <a:t>02</a:t>
+            </a:r>
+          </a:p>
+        </p:txBody>
+      </p:sp>
+      <p:sp>
+        <p:nvSpPr>
+          <p:cNvPr id="17" name="TextBox 16"/>
+          <p:cNvSpPr txBox="1"/>
+          <p:nvPr/>
+        </p:nvSpPr>
+        <p:spPr>
+          <a:xfrm>
+            <a:off x="1307592" y="4160520"/>
+            <a:ext cx="4681728" cy="283464"/>
+          </a:xfrm>
+          <a:prstGeom prst="rect">
+            <a:avLst/>
+          </a:prstGeom>
+          <a:noFill/>
+          <a:effectLst/>
+        </p:spPr>
+        <p:txBody>
+          <a:bodyPr wrap="none" lIns="0" rIns="0" tIns="0" bIns="0">
+            <a:spAutoFit/>
+          </a:bodyPr>
+          <a:lstStyle/>
+          <a:p>
+            <a:pPr>
+              <a:spcAft>
+                <a:spcPts val="700"/>
+              </a:spcAft>
+              <a:defRPr sz="1300" b="0">
+                <a:solidFill>
+                  <a:srgbClr val="142B46"/>
+                </a:solidFill>
+                <a:latin typeface="Noto Sans CJK SC"/>
+              </a:defRPr>
+            </a:pPr>
+            <a:r>
+              <a:t>训练一个模型，判断是否该只用目标方向</a:t>
+            </a:r>
+          </a:p>
+        </p:txBody>
+      </p:sp>
+      <p:sp>
+        <p:nvSpPr>
+          <p:cNvPr id="18" name="TextBox 17"/>
+          <p:cNvSpPr txBox="1"/>
+          <p:nvPr/>
+        </p:nvSpPr>
+        <p:spPr>
+          <a:xfrm>
+            <a:off x="6217920" y="4160520"/>
+            <a:ext cx="5074920" cy="283464"/>
+          </a:xfrm>
+          <a:prstGeom prst="rect">
+            <a:avLst/>
+          </a:prstGeom>
+          <a:noFill/>
+          <a:effectLst/>
+        </p:spPr>
+        <p:txBody>
+          <a:bodyPr wrap="none" lIns="0" rIns="0" tIns="0" bIns="0">
+            <a:spAutoFit/>
+          </a:bodyPr>
+          <a:lstStyle/>
+          <a:p>
+            <a:pPr>
+              <a:spcAft>
+                <a:spcPts val="700"/>
+              </a:spcAft>
+              <a:defRPr sz="1300" b="0">
+                <a:solidFill>
+                  <a:srgbClr val="142B46"/>
+                </a:solidFill>
+                <a:latin typeface="Noto Sans CJK SC"/>
+              </a:defRPr>
+            </a:pPr>
+            <a:r>
+              <a:t>判断能力接近随机猜测，未提高条件收益。</a:t>
+            </a:r>
+          </a:p>
+        </p:txBody>
+      </p:sp>
+      <p:sp>
+        <p:nvSpPr>
+          <p:cNvPr id="19" name="Rounded Rectangle 18"/>
+          <p:cNvSpPr/>
+          <p:nvPr/>
+        </p:nvSpPr>
+        <p:spPr>
+          <a:xfrm>
+            <a:off x="685800" y="4571999"/>
+            <a:ext cx="10826496" cy="411480"/>
+          </a:xfrm>
+          <a:prstGeom prst="roundRect">
+            <a:avLst>
+              <a:gd name="adj" fmla="val 12000"/>
+            </a:avLst>
+          </a:prstGeom>
+          <a:solidFill>
+            <a:srgbClr val="F0F4F8"/>
+          </a:solidFill>
+          <a:ln>
+            <a:noFill/>
+          </a:ln>
+          <a:effectLst/>
+        </p:spPr>
+        <p:style>
+          <a:lnRef idx="1">
+            <a:schemeClr val="accent1"/>
+          </a:lnRef>
+          <a:fillRef idx="3">
+            <a:schemeClr val="accent1"/>
+          </a:fillRef>
+          <a:effectRef idx="0">
+            <a:schemeClr val="accent1"/>
+          </a:effectRef>
+          <a:fontRef idx="minor">
+            <a:schemeClr val="lt1"/>
+          </a:fontRef>
+        </p:style>
+        <p:txBody>
+          <a:bodyPr rtlCol="0" anchor="ctr"/>
+          <a:lstStyle/>
+          <a:p>
+            <a:pPr algn="ctr"/>
+          </a:p>
+        </p:txBody>
+      </p:sp>
+      <p:sp>
+        <p:nvSpPr>
+          <p:cNvPr id="20" name="TextBox 19"/>
+          <p:cNvSpPr txBox="1"/>
+          <p:nvPr/>
+        </p:nvSpPr>
+        <p:spPr>
+          <a:xfrm>
+            <a:off x="841248" y="4608575"/>
+            <a:ext cx="365760" cy="256032"/>
+          </a:xfrm>
+          <a:prstGeom prst="rect">
+            <a:avLst/>
+          </a:prstGeom>
+          <a:noFill/>
+          <a:effectLst/>
+        </p:spPr>
+        <p:txBody>
+          <a:bodyPr wrap="none" lIns="0" rIns="0" tIns="0" bIns="0">
+            <a:spAutoFit/>
+          </a:bodyPr>
+          <a:lstStyle/>
+          <a:p>
+            <a:pPr>
+              <a:spcAft>
+                <a:spcPts val="700"/>
+              </a:spcAft>
+              <a:defRPr sz="1100" b="1">
+                <a:solidFill>
+                  <a:srgbClr val="148D91"/>
+                </a:solidFill>
+                <a:latin typeface="Noto Sans CJK SC"/>
+              </a:defRPr>
+            </a:pPr>
+            <a:r>
+              <a:t>03</a:t>
+            </a:r>
+          </a:p>
+        </p:txBody>
+      </p:sp>
+      <p:sp>
+        <p:nvSpPr>
+          <p:cNvPr id="21" name="TextBox 20"/>
+          <p:cNvSpPr txBox="1"/>
+          <p:nvPr/>
+        </p:nvSpPr>
+        <p:spPr>
+          <a:xfrm>
+            <a:off x="1307592" y="4608575"/>
+            <a:ext cx="4681728" cy="283464"/>
+          </a:xfrm>
+          <a:prstGeom prst="rect">
+            <a:avLst/>
+          </a:prstGeom>
+          <a:noFill/>
+          <a:effectLst/>
+        </p:spPr>
+        <p:txBody>
+          <a:bodyPr wrap="none" lIns="0" rIns="0" tIns="0" bIns="0">
+            <a:spAutoFit/>
+          </a:bodyPr>
+          <a:lstStyle/>
+          <a:p>
+            <a:pPr>
+              <a:spcAft>
+                <a:spcPts val="700"/>
+              </a:spcAft>
+              <a:defRPr sz="1300" b="0">
+                <a:solidFill>
+                  <a:srgbClr val="142B46"/>
+                </a:solidFill>
+                <a:latin typeface="Noto Sans CJK SC"/>
+              </a:defRPr>
+            </a:pPr>
+            <a:r>
+              <a:t>让模型自动降低航点的影响</a:t>
+            </a:r>
+          </a:p>
+        </p:txBody>
+      </p:sp>
+      <p:sp>
+        <p:nvSpPr>
+          <p:cNvPr id="22" name="TextBox 21"/>
+          <p:cNvSpPr txBox="1"/>
+          <p:nvPr/>
+        </p:nvSpPr>
+        <p:spPr>
+          <a:xfrm>
+            <a:off x="6217920" y="4608575"/>
+            <a:ext cx="5074920" cy="283464"/>
+          </a:xfrm>
+          <a:prstGeom prst="rect">
+            <a:avLst/>
+          </a:prstGeom>
+          <a:noFill/>
+          <a:effectLst/>
+        </p:spPr>
+        <p:txBody>
+          <a:bodyPr wrap="none" lIns="0" rIns="0" tIns="0" bIns="0">
+            <a:spAutoFit/>
+          </a:bodyPr>
+          <a:lstStyle/>
+          <a:p>
+            <a:pPr>
+              <a:spcAft>
+                <a:spcPts val="700"/>
+              </a:spcAft>
+              <a:defRPr sz="1300" b="0">
+                <a:solidFill>
+                  <a:srgbClr val="142B46"/>
+                </a:solidFill>
+                <a:latin typeface="Noto Sans CJK SC"/>
+              </a:defRPr>
+            </a:pPr>
+            <a:r>
+              <a:t>模型几乎不作调整，效果接近原方法。</a:t>
+            </a:r>
+          </a:p>
+        </p:txBody>
+      </p:sp>
+      <p:sp>
+        <p:nvSpPr>
+          <p:cNvPr id="23" name="TextBox 22"/>
+          <p:cNvSpPr txBox="1"/>
+          <p:nvPr/>
+        </p:nvSpPr>
+        <p:spPr>
+          <a:xfrm>
+            <a:off x="841248" y="5056631"/>
+            <a:ext cx="365760" cy="256032"/>
+          </a:xfrm>
+          <a:prstGeom prst="rect">
+            <a:avLst/>
+          </a:prstGeom>
+          <a:noFill/>
+          <a:effectLst/>
+        </p:spPr>
+        <p:txBody>
+          <a:bodyPr wrap="none" lIns="0" rIns="0" tIns="0" bIns="0">
+            <a:spAutoFit/>
+          </a:bodyPr>
+          <a:lstStyle/>
+          <a:p>
+            <a:pPr>
+              <a:spcAft>
+                <a:spcPts val="700"/>
+              </a:spcAft>
+              <a:defRPr sz="1100" b="1">
+                <a:solidFill>
+                  <a:srgbClr val="148D91"/>
+                </a:solidFill>
+                <a:latin typeface="Noto Sans CJK SC"/>
+              </a:defRPr>
+            </a:pPr>
+            <a:r>
+              <a:t>04</a:t>
+            </a:r>
+          </a:p>
+        </p:txBody>
+      </p:sp>
+      <p:sp>
+        <p:nvSpPr>
+          <p:cNvPr id="24" name="TextBox 23"/>
+          <p:cNvSpPr txBox="1"/>
+          <p:nvPr/>
+        </p:nvSpPr>
+        <p:spPr>
+          <a:xfrm>
+            <a:off x="1307592" y="5056631"/>
+            <a:ext cx="4681728" cy="283464"/>
+          </a:xfrm>
+          <a:prstGeom prst="rect">
+            <a:avLst/>
+          </a:prstGeom>
+          <a:noFill/>
+          <a:effectLst/>
+        </p:spPr>
+        <p:txBody>
+          <a:bodyPr wrap="none" lIns="0" rIns="0" tIns="0" bIns="0">
+            <a:spAutoFit/>
+          </a:bodyPr>
+          <a:lstStyle/>
+          <a:p>
+            <a:pPr>
+              <a:spcAft>
+                <a:spcPts val="700"/>
+              </a:spcAft>
+              <a:defRPr sz="1300" b="0">
+                <a:solidFill>
+                  <a:srgbClr val="142B46"/>
+                </a:solidFill>
+                <a:latin typeface="Noto Sans CJK SC"/>
+              </a:defRPr>
+            </a:pPr>
+            <a:r>
+              <a:t>两种方向分歧大时，就减少航点权重</a:t>
+            </a:r>
+          </a:p>
+        </p:txBody>
+      </p:sp>
+      <p:sp>
+        <p:nvSpPr>
+          <p:cNvPr id="25" name="TextBox 24"/>
+          <p:cNvSpPr txBox="1"/>
+          <p:nvPr/>
+        </p:nvSpPr>
+        <p:spPr>
+          <a:xfrm>
+            <a:off x="6217920" y="5056631"/>
+            <a:ext cx="5074920" cy="283464"/>
+          </a:xfrm>
+          <a:prstGeom prst="rect">
+            <a:avLst/>
+          </a:prstGeom>
+          <a:noFill/>
+          <a:effectLst/>
+        </p:spPr>
+        <p:txBody>
+          <a:bodyPr wrap="none" lIns="0" rIns="0" tIns="0" bIns="0">
+            <a:spAutoFit/>
+          </a:bodyPr>
+          <a:lstStyle/>
+          <a:p>
+            <a:pPr>
+              <a:spcAft>
+                <a:spcPts val="700"/>
+              </a:spcAft>
+              <a:defRPr sz="1300" b="1">
+                <a:solidFill>
+                  <a:srgbClr val="148D91"/>
+                </a:solidFill>
+                <a:latin typeface="Noto Sans CJK SC"/>
+              </a:defRPr>
+            </a:pPr>
+            <a:r>
+              <a:t>条件收益从 2.80 降至 2.24 cm，反而更差。</a:t>
+            </a:r>
+          </a:p>
+        </p:txBody>
+      </p:sp>
+      <p:sp>
+        <p:nvSpPr>
+          <p:cNvPr id="26" name="TextBox 25"/>
+          <p:cNvSpPr txBox="1"/>
+          <p:nvPr/>
+        </p:nvSpPr>
+        <p:spPr>
+          <a:xfrm>
+            <a:off x="685800" y="5596128"/>
+            <a:ext cx="10826496" cy="256032"/>
+          </a:xfrm>
+          <a:prstGeom prst="rect">
+            <a:avLst/>
+          </a:prstGeom>
+          <a:noFill/>
+          <a:effectLst/>
+        </p:spPr>
+        <p:txBody>
+          <a:bodyPr wrap="none" lIns="0" rIns="0" tIns="0" bIns="0">
+            <a:spAutoFit/>
+          </a:bodyPr>
+          <a:lstStyle/>
+          <a:p>
+            <a:pPr>
+              <a:spcAft>
+                <a:spcPts val="700"/>
+              </a:spcAft>
+              <a:defRPr sz="1000" b="0">
+                <a:solidFill>
+                  <a:srgbClr val="62748A"/>
+                </a:solidFill>
+                <a:latin typeface="Noto Sans CJK SC"/>
+              </a:defRPr>
+            </a:pPr>
+            <a:r>
+              <a:t>说明：条件收益表示加入目标信息后误差减少了多少，越大越好；上述结果分别与各自的原方法比较。</a:t>
+            </a:r>
+          </a:p>
+        </p:txBody>
+      </p:sp>
+      <p:sp>
+        <p:nvSpPr>
+          <p:cNvPr id="27" name="TextBox 26"/>
+          <p:cNvSpPr txBox="1"/>
+          <p:nvPr/>
+        </p:nvSpPr>
+        <p:spPr>
+          <a:xfrm>
+            <a:off x="685800" y="5907024"/>
+            <a:ext cx="10826496" cy="246888"/>
+          </a:xfrm>
+          <a:prstGeom prst="rect">
+            <a:avLst/>
+          </a:prstGeom>
+          <a:noFill/>
+          <a:effectLst/>
+        </p:spPr>
+        <p:txBody>
+          <a:bodyPr wrap="none" lIns="0" rIns="0" tIns="0" bIns="0">
+            <a:spAutoFit/>
+          </a:bodyPr>
+          <a:lstStyle/>
+          <a:p>
+            <a:pPr>
+              <a:spcAft>
+                <a:spcPts val="700"/>
+              </a:spcAft>
+              <a:defRPr sz="1000" b="0">
+                <a:solidFill>
+                  <a:srgbClr val="62748A"/>
+                </a:solidFill>
+                <a:latin typeface="Noto Sans CJK SC"/>
+              </a:defRPr>
+            </a:pPr>
+            <a:r>
+              <a:t>其中部分模型使用了真实未来轨迹信息，仅为离线分析，尚不能直接用于实机。</a:t>
+            </a:r>
+          </a:p>
+        </p:txBody>
+      </p:sp>
+      <p:sp>
+        <p:nvSpPr>
+          <p:cNvPr id="28" name="Rounded Rectangle 27"/>
+          <p:cNvSpPr/>
+          <p:nvPr/>
+        </p:nvSpPr>
+        <p:spPr>
+          <a:xfrm>
+            <a:off x="685800" y="6254496"/>
+            <a:ext cx="10826496" cy="365760"/>
+          </a:xfrm>
+          <a:prstGeom prst="roundRect">
+            <a:avLst>
+              <a:gd name="adj" fmla="val 12000"/>
+            </a:avLst>
+          </a:prstGeom>
+          <a:solidFill>
+            <a:srgbClr val="E8F4F2"/>
+          </a:solidFill>
+          <a:ln>
+            <a:noFill/>
+          </a:ln>
+          <a:effectLst/>
+        </p:spPr>
+        <p:style>
+          <a:lnRef idx="1">
+            <a:schemeClr val="accent1"/>
+          </a:lnRef>
+          <a:fillRef idx="3">
+            <a:schemeClr val="accent1"/>
+          </a:fillRef>
+          <a:effectRef idx="0">
+            <a:schemeClr val="accent1"/>
+          </a:effectRef>
+          <a:fontRef idx="minor">
+            <a:schemeClr val="lt1"/>
+          </a:fontRef>
+        </p:style>
+        <p:txBody>
+          <a:bodyPr rtlCol="0" anchor="ctr"/>
+          <a:lstStyle/>
+          <a:p>
+            <a:pPr algn="ctr"/>
+          </a:p>
+        </p:txBody>
+      </p:sp>
+      <p:sp>
+        <p:nvSpPr>
+          <p:cNvPr id="29" name="TextBox 28"/>
+          <p:cNvSpPr txBox="1"/>
+          <p:nvPr/>
+        </p:nvSpPr>
+        <p:spPr>
+          <a:xfrm>
+            <a:off x="859536" y="6309360"/>
+            <a:ext cx="10424160" cy="256032"/>
           </a:xfrm>
           <a:prstGeom prst="rect">
             <a:avLst/>
@@ -5189,20 +4710,20 @@
               </a:defRPr>
             </a:pPr>
             <a:r>
-              <a:t>结论：这些门控尝试尚未形成稳定升级，下一步优先改善 WP 方向估计。</a:t>
-            </a:r>
-          </a:p>
-        </p:txBody>
-      </p:sp>
-      <p:sp>
-        <p:nvSpPr>
-          <p:cNvPr id="42" name="TextBox 41"/>
+              <a:t>启示：先把航点方向预测得更准，比继续增加这些判断规则更值得优先尝试。</a:t>
+            </a:r>
+          </a:p>
+        </p:txBody>
+      </p:sp>
+      <p:sp>
+        <p:nvSpPr>
+          <p:cNvPr id="30" name="TextBox 29"/>
           <p:cNvSpPr txBox="1"/>
           <p:nvPr/>
         </p:nvSpPr>
         <p:spPr>
           <a:xfrm>
-            <a:off x="685800" y="6675120"/>
+            <a:off x="685800" y="6684264"/>
             <a:ext cx="10058400" cy="146304"/>
           </a:xfrm>
           <a:prstGeom prst="rect">
@@ -5229,20 +4750,20 @@
               </a:defRPr>
             </a:pPr>
             <a:r>
-              <a:t>来源：p5ab_summary.txt、p5b/c summary.json、kappa_fusion_summary.txt；均为 locked 1000 帧相关分析。</a:t>
-            </a:r>
-          </a:p>
-        </p:txBody>
-      </p:sp>
-      <p:sp>
-        <p:nvSpPr>
-          <p:cNvPr id="43" name="TextBox 42"/>
+              <a:t>来源：p5ab_summary.txt、p5b/c summary.json、kappa_fusion_summary.txt；技术细节与评估口径见备注。</a:t>
+            </a:r>
+          </a:p>
+        </p:txBody>
+      </p:sp>
+      <p:sp>
+        <p:nvSpPr>
+          <p:cNvPr id="31" name="TextBox 30"/>
           <p:cNvSpPr txBox="1"/>
           <p:nvPr/>
         </p:nvSpPr>
         <p:spPr>
           <a:xfrm>
-            <a:off x="10506456" y="6675120"/>
+            <a:off x="10506456" y="6684264"/>
             <a:ext cx="960120" cy="146304"/>
           </a:xfrm>
           <a:prstGeom prst="rect">
@@ -5269,7 +4790,7 @@
               </a:defRPr>
             </a:pPr>
             <a:r>
-              <a:t>融合门控 / 09</a:t>
+              <a:t>信任判断 / 09</a:t>
             </a:r>
           </a:p>
         </p:txBody>

</xml_diff>

<commit_message>
Explain P5 error labels and suppression rules and qualify regression result
</commit_message>
<xml_diff>
--- a/presentations/slide09_confidence_gating_cn.pptx
+++ b/presentations/slide09_confidence_gating_cn.pptx
@@ -502,60 +502,60 @@
           <a:lstStyle/>
           <a:p>
             <a:r>
-              <a:t>第9页，独立单页文件。来源：main c1b3750的train/logs/revalidation/p5ab_summary.txt、p5b_harmful_predictor/summary.json、p5c_trust/summary.json、kappa_fusion_summary.txt；并检查train/run_p5b_harmful_predictor.py、eval_frame_sets.py、adaptive_blend.py。</a:t>
-            </a:r>
-          </a:p>
-          <a:p>
-            <a:r>
-              <a:t>有害harmful=ADE_blend&gt;ADE_goal，非WP误差大于某阈值；P5a中WP相对权重r_w=κ_wp/(κ_wp+κ_goal)，有害/有益Cohen d=-0.04，不支持相对权重系统性过高的简单假说，不等于证明κ整体已校准。</a:t>
-            </a:r>
-          </a:p>
-          <a:p>
-            <a:r>
-              <a:t>P5b按轨迹5-fold GroupKFold，折外AUC=0.5200512964；已有ADE反事实：κ2.6199888861，best_oof2.6199888861（frac_goal=0），oracle_pick3.8031935437cm。阈值搜索结果是离线描述，不是额外独立测试或重复种子验证。</a:t>
-            </a:r>
-          </a:p>
-          <a:p>
-            <a:r>
-              <a:t>P5c rollout：κ2.6943408467，trust OOF ridge2.6915933922，trust surrogate-oracle s*3.5913267216cm；平均s_hat约0.027来自p5ab_summary.txt。s*基于已有blend/goal ADE代理选取，再rollout，不是GT WP方向Oracle，也不是真实目标的理论上界。</a:t>
-            </a:r>
-          </a:p>
-          <a:p>
-            <a:r>
-              <a:t>固定分歧门控同批rollout（kappa_fusion_summary.txt）：κ2.80，goal-WP disagree 35–55deg抑制2.24，GT WP误差Oracle抑制3.16cm。不能把2.62/2.69/2.80当同协议可交换基线。所有离线参考定义不同，不能跨行比较其大小。</a:t>
-            </a:r>
-          </a:p>
-          <a:p>
-            <a:r>
-              <a:t>P5b/c特征含turn_strict、yaw8_deg、endpoint_lateral_m等真实未来轨迹派生信息（从归因缓存读取）；虽未直接使用GT WP误差，也不能称为全部部署可用特征。页面已明确只作离线探索。</a:t>
-            </a:r>
-          </a:p>
-          <a:p>
-            <a:r>
-              <a:t>其他探索（未加入主表，避免混用）：goal-only fallback在P5b同ADE基线下2.03&lt;κ2.62；约束fallback2.73&gt;同批2.62，但在locked上扫参，不能描述为全面无收益或独立测试证据，也不能直接用其与另一批ctx2/turnhard排名。</a:t>
-            </a:r>
-          </a:p>
-          <a:p>
-            <a:r>
-              <a:t>本页不声称统计显著、不推广为所有门控均无效，暂不将缺少核对来源的learned temperature数值写入。</a:t>
+              <a:t>第9页细节重写，独立单页；按用户要求只更新单页PPT/PDF/PNG，不更新合并版。</a:t>
+            </a:r>
+          </a:p>
+          <a:p>
+            <a:r>
+              <a:t>实质更正：不再将P5c低抑制输出直接解释成“学会永远相信κ”，不再称其标签来自真实重跑21个抑制强度。</a:t>
+            </a:r>
+          </a:p>
+          <a:p>
+            <a:r>
+              <a:t>1. ADE来自train/eval_by_distance.py:ade_fde，预测[N,T,2]、真实[T,2]按对应步减差并乘meters_per_unit，欧氏距离在T步平均；eval_position_noise.py:mean_ade_fde再对采样轨迹平均。eval_testtime.py:rollout固定观测、策略与B距离，分别评估不同位置条件；P5c为8条采样，每条8点，条件间复用同批噪声。不是实际闭环机器人rollout。</a:t>
+            </a:r>
+          </a:p>
+          <a:p>
+            <a:r>
+              <a:t>记e_b=已有ADE_Db_d_blend，e_g=已有ADE_Db_dg_pred。harmful=(e_b-e_g)&gt;0，等误差视为非有害；y=1表示只用目标更好。use_cm=100*(ADE_mask-ADE_condition)，因此按ADE优劣分组等价于相同mask参考下的收益优劣。</a:t>
+            </a:r>
+          </a:p>
+          <a:p>
+            <a:r>
+              <a:t>01 P5a来自p5ab_summary.txt：r_w=κ_wp/(κ_wp+κ_g)，harmful median.701 vs beneficial.719；描述统计，不训练网络，不证明κ完全校准。</a:t>
+            </a:r>
+          </a:p>
+          <a:p>
+            <a:r>
+              <a:t>02 run_p5b_harmful_predictor.py：特征theta,rw,logkw,logkg,turnstrict,yaw8,spread,turnloose,endpointlateral，训练集标准化，逻辑回归BCE+L2正则，按轨迹5组轮换训练/折外预测。OOF概率阈值在.05..95扫描，报告best thr=.6；该阈值frac_goal0，use保持2.61999。AUC.520051。阈值是在同一locked相关集合挑选，不能称独立部署验证。部分输入含GT未来运动信息。</a:t>
+            </a:r>
+          </a:p>
+          <a:p>
+            <a:r>
+              <a:t>03 run_p5c_trust.py:GRID_S=linspace(0,1,21)，optimal_s_surrogate只计算(1-s)*e_b+s*e_g，按strict improvement选最小值。因为目标为直线，理想数学情况下s*=1当e_g&lt;e_b，否则0（等值保留0）；不是对21个真实中间方向逐次采样策略得到最优值，不能当真实连续最优抑制标签。后续fit_ridge_predict标准化输入A=(X-mu)/sig，求w=(A^T A+lambda I)^-1 A^T s*，main lambda2，pred=clip(Ate w,0,1)，按轨迹5组轮换。再以预测s_hat重算blend_suppress并运行策略评估。</a:t>
+            </a:r>
+          </a:p>
+          <a:p>
+            <a:r>
+              <a:t>03实现问题：输入列均值为零，但无截距也未对标签中心化后加回均值，训练集未截断预测均值必为零，不能表达非零目标均值，截断进一步改变分布。已有mean_s_hat.027、rollout≈κ的结果可能受此结构性偏置影响；需修正截距或中心化y+恢复均值后重评，不能将当前结果当成学习信任机制已失败。没有在本任务中修改训练脚本或重跑实验。</a:t>
+            </a:r>
+          </a:p>
+          <a:p>
+            <a:r>
+              <a:t>04 adaptive_blend.py:angle_between_deg先归一化方向并clip点积到[-1,1]再acos转deg；s=clip((theta-35)/(55-35),0,1)，本例turn_weight0,cap1,wp_scale1。κ_wp'=(1-s)κ_wp，κ_g不变，混合向量归一化，乘B距离形成位置条件。0/0.5/1抑制分别保留100%/50%/0%航点权重。θ是预测Goal与预测WP的夹角，不是真实WP误差。</a:t>
+            </a:r>
+          </a:p>
+          <a:p>
+            <a:r>
+              <a:t>04 35–55deg首先在GT WP误差Oracle条件下扫参，拿去用预测方向分歧不保证同分布。kappa_fusion_summary.txt同批ctx2：κ2.80，disagree固定门控2.24，GT误差门控3.16，单位cm。不同批的P5b2.62、P5c2.69不能与此直接排名。</a:t>
+            </a:r>
+          </a:p>
+          <a:p>
+            <a:r>
+              <a:t>本文未声称实际标签或模型特征均在线可用，也未把GT误差门控称可部署方法。只有离线已有结果、代码诊断，不代表独立测试或重复种子显著性。</a:t>
             </a:r>
           </a:p>
           <a:p/>
-          <a:p>
-            <a:r>
-              <a:t>通俗表达修订：页面移除AUC、OOF、rollout、反事实及Oracle等专有词，详细定义仍保留于以上备注。四行依次对应P5a、P5b、P5c与固定分歧门控；只有最后一行展示数值，且2.80→2.24来自同批评估。未展示不能部署的离线参考上界，未将不同批次直接排名。结论仅针对这些已试方案，不证明所有门控均无效。</a:t>
-            </a:r>
-          </a:p>
-          <a:p>
-            <a:r>
-              <a:t>通俗表达修订：页面移除AUC、OOF、rollout、反事实及Oracle等专有词，详细定义仍保留于以上备注。四行依次对应P5a、P5b、P5c与固定分歧门控；只有最后一行展示数值，且2.80→2.24来自同批评估。未展示不能部署的离线参考上界，未将不同批次直接排名。结论仅针对这些已试方案，不证明所有门控均无效。</a:t>
-            </a:r>
-          </a:p>
-          <a:p>
-            <a:r>
-              <a:t>通俗表达修订：页面移除AUC、OOF、rollout、反事实及Oracle等专有词，详细定义仍保留于以上备注。四行依次对应P5a、P5b、P5c与固定分歧门控；只有最后一行展示数值，且2.80→2.24来自同批评估。未展示不能部署的离线参考上界，未将不同批次直接排名。结论仅针对这些已试方案，不证明所有门控均无效。</a:t>
-            </a:r>
-          </a:p>
         </p:txBody>
       </p:sp>
       <p:sp>
@@ -3690,7 +3690,7 @@
               </a:defRPr>
             </a:pPr>
             <a:r>
-              <a:t>P5 / 调整两种方向的信任程度</a:t>
+              <a:t>P5 / 航点降权：误差、标签与具体规则</a:t>
             </a:r>
           </a:p>
         </p:txBody>
@@ -3722,7 +3722,7 @@
               <a:spcAft>
                 <a:spcPts val="700"/>
               </a:spcAft>
-              <a:defRPr sz="2900" b="1">
+              <a:defRPr sz="2600" b="1">
                 <a:solidFill>
                   <a:srgbClr val="142B46"/>
                 </a:solidFill>
@@ -3730,7 +3730,7 @@
               </a:defRPr>
             </a:pPr>
             <a:r>
-              <a:t>什么时候应该少信航点方向？</a:t>
+              <a:t>什么时候少信航点？具体怎样算、怎样改？</a:t>
             </a:r>
           </a:p>
         </p:txBody>
@@ -3743,8 +3743,8 @@
         </p:nvSpPr>
         <p:spPr>
           <a:xfrm>
-            <a:off x="685800" y="1719072"/>
-            <a:ext cx="10972800" cy="310896"/>
+            <a:off x="685800" y="1645920"/>
+            <a:ext cx="10972800" cy="256032"/>
           </a:xfrm>
           <a:prstGeom prst="rect">
             <a:avLst/>
@@ -3762,7 +3762,7 @@
               <a:spcAft>
                 <a:spcPts val="700"/>
               </a:spcAft>
-              <a:defRPr sz="1400" b="0">
+              <a:defRPr sz="1200" b="0">
                 <a:solidFill>
                   <a:srgbClr val="62748A"/>
                 </a:solidFill>
@@ -3770,7 +3770,7 @@
               </a:defRPr>
             </a:pPr>
             <a:r>
-              <a:t>目标方向：目标在哪里 · 航点方向：接下来往哪里走 · 两者有时会相互冲突</a:t>
+              <a:t>四项独立实验，方向头与扩散策略保持冻结；先用真实轨迹判断融合是否让预测变差。</a:t>
             </a:r>
           </a:p>
         </p:txBody>
@@ -3783,8 +3783,8 @@
         </p:nvSpPr>
         <p:spPr>
           <a:xfrm>
-            <a:off x="685800" y="2249424"/>
-            <a:ext cx="10826496" cy="576072"/>
+            <a:off x="685800" y="2011680"/>
+            <a:ext cx="10826496" cy="557784"/>
           </a:xfrm>
           <a:prstGeom prst="roundRect">
             <a:avLst>
@@ -3829,8 +3829,8 @@
         </p:nvSpPr>
         <p:spPr>
           <a:xfrm>
-            <a:off x="859536" y="2423160"/>
-            <a:ext cx="10424160" cy="283464"/>
+            <a:off x="859536" y="2121408"/>
+            <a:ext cx="5166360" cy="265176"/>
           </a:xfrm>
           <a:prstGeom prst="rect">
             <a:avLst/>
@@ -3856,7 +3856,7 @@
               </a:defRPr>
             </a:pPr>
             <a:r>
-              <a:t>原方法：根据两种预测的置信度，决定各自占多大比重。</a:t>
+              <a:t>ADE = ⅛ ∑ₖ ‖p̂ₖ − pₖ‖₂（k=1,…,8）</a:t>
             </a:r>
           </a:p>
         </p:txBody>
@@ -3869,8 +3869,8 @@
         </p:nvSpPr>
         <p:spPr>
           <a:xfrm>
-            <a:off x="841248" y="3099816"/>
-            <a:ext cx="4846320" cy="292608"/>
+            <a:off x="6263640" y="2093976"/>
+            <a:ext cx="5010912" cy="201168"/>
           </a:xfrm>
           <a:prstGeom prst="rect">
             <a:avLst/>
@@ -3888,15 +3888,15 @@
               <a:spcAft>
                 <a:spcPts val="700"/>
               </a:spcAft>
-              <a:defRPr sz="1600" b="1">
+              <a:defRPr sz="900" b="0">
                 <a:solidFill>
-                  <a:srgbClr val="142B46"/>
+                  <a:srgbClr val="62748A"/>
                 </a:solidFill>
                 <a:latin typeface="Noto Sans CJK SC"/>
               </a:defRPr>
             </a:pPr>
             <a:r>
-              <a:t>我们尝试了什么？</a:t>
+              <a:t>p̂ₖ / pₖ：预测 / 真实位置（米）；先平均 8 步误差，再平均采样。</a:t>
             </a:r>
           </a:p>
         </p:txBody>
@@ -3909,8 +3909,8 @@
         </p:nvSpPr>
         <p:spPr>
           <a:xfrm>
-            <a:off x="6217920" y="3099816"/>
-            <a:ext cx="4937760" cy="292608"/>
+            <a:off x="6263640" y="2386584"/>
+            <a:ext cx="5010912" cy="173736"/>
           </a:xfrm>
           <a:prstGeom prst="rect">
             <a:avLst/>
@@ -3928,65 +3928,29 @@
               <a:spcAft>
                 <a:spcPts val="700"/>
               </a:spcAft>
-              <a:defRPr sz="1600" b="1">
+              <a:defRPr sz="900" b="0">
                 <a:solidFill>
-                  <a:srgbClr val="142B46"/>
+                  <a:srgbClr val="62748A"/>
                 </a:solidFill>
                 <a:latin typeface="Noto Sans CJK SC"/>
               </a:defRPr>
             </a:pPr>
             <a:r>
-              <a:t>结果怎么样？</a:t>
-            </a:r>
-          </a:p>
-        </p:txBody>
-      </p:sp>
-      <p:cxnSp>
-        <p:nvCxnSpPr>
-          <p:cNvPr id="11" name="Connector 10"/>
-          <p:cNvCxnSpPr/>
-          <p:nvPr/>
-        </p:nvCxnSpPr>
-        <p:spPr>
-          <a:xfrm>
-            <a:off x="685800" y="3520440"/>
-            <a:ext cx="10826496" cy="0"/>
-          </a:xfrm>
-          <a:prstGeom prst="line">
-            <a:avLst/>
-          </a:prstGeom>
-          <a:ln w="10160">
-            <a:solidFill>
-              <a:srgbClr val="DCE5EF"/>
-            </a:solidFill>
-          </a:ln>
-          <a:effectLst/>
-        </p:spPr>
-        <p:style>
-          <a:lnRef idx="2">
-            <a:schemeClr val="accent1"/>
-          </a:lnRef>
-          <a:fillRef idx="0">
-            <a:schemeClr val="accent1"/>
-          </a:fillRef>
-          <a:effectRef idx="0">
-            <a:schemeClr val="accent1"/>
-          </a:effectRef>
-          <a:fontRef idx="minor">
-            <a:schemeClr val="tx1"/>
-          </a:fontRef>
-        </p:style>
-      </p:cxnSp>
-      <p:sp>
-        <p:nvSpPr>
-          <p:cNvPr id="12" name="Rounded Rectangle 11"/>
+              <a:t>e_b：融合条件的 ADE；e_g：仅目标方向条件的 ADE。</a:t>
+            </a:r>
+          </a:p>
+        </p:txBody>
+      </p:sp>
+      <p:sp>
+        <p:nvSpPr>
+          <p:cNvPr id="11" name="Rounded Rectangle 10"/>
           <p:cNvSpPr/>
           <p:nvPr/>
         </p:nvSpPr>
         <p:spPr>
           <a:xfrm>
-            <a:off x="685800" y="3675887"/>
-            <a:ext cx="10826496" cy="411480"/>
+            <a:off x="685800" y="2734056"/>
+            <a:ext cx="5303520" cy="1197864"/>
           </a:xfrm>
           <a:prstGeom prst="roundRect">
             <a:avLst>
@@ -4025,14 +3989,14 @@
       </p:sp>
       <p:sp>
         <p:nvSpPr>
-          <p:cNvPr id="13" name="TextBox 12"/>
+          <p:cNvPr id="12" name="TextBox 11"/>
           <p:cNvSpPr txBox="1"/>
           <p:nvPr/>
         </p:nvSpPr>
         <p:spPr>
           <a:xfrm>
-            <a:off x="841248" y="3712463"/>
-            <a:ext cx="365760" cy="256032"/>
+            <a:off x="850392" y="2834640"/>
+            <a:ext cx="4974336" cy="274320"/>
           </a:xfrm>
           <a:prstGeom prst="rect">
             <a:avLst/>
@@ -4050,47 +4014,7 @@
               <a:spcAft>
                 <a:spcPts val="700"/>
               </a:spcAft>
-              <a:defRPr sz="1100" b="1">
-                <a:solidFill>
-                  <a:srgbClr val="148D91"/>
-                </a:solidFill>
-                <a:latin typeface="Noto Sans CJK SC"/>
-              </a:defRPr>
-            </a:pPr>
-            <a:r>
-              <a:t>01</a:t>
-            </a:r>
-          </a:p>
-        </p:txBody>
-      </p:sp>
-      <p:sp>
-        <p:nvSpPr>
-          <p:cNvPr id="14" name="TextBox 13"/>
-          <p:cNvSpPr txBox="1"/>
-          <p:nvPr/>
-        </p:nvSpPr>
-        <p:spPr>
-          <a:xfrm>
-            <a:off x="1307592" y="3712463"/>
-            <a:ext cx="4681728" cy="283464"/>
-          </a:xfrm>
-          <a:prstGeom prst="rect">
-            <a:avLst/>
-          </a:prstGeom>
-          <a:noFill/>
-          <a:effectLst/>
-        </p:spPr>
-        <p:txBody>
-          <a:bodyPr wrap="none" lIns="0" rIns="0" tIns="0" bIns="0">
-            <a:spAutoFit/>
-          </a:bodyPr>
-          <a:lstStyle/>
-          <a:p>
-            <a:pPr>
-              <a:spcAft>
-                <a:spcPts val="700"/>
-              </a:spcAft>
-              <a:defRPr sz="1300" b="0">
+              <a:defRPr sz="1400" b="1">
                 <a:solidFill>
                   <a:srgbClr val="142B46"/>
                 </a:solidFill>
@@ -4098,21 +4022,21 @@
               </a:defRPr>
             </a:pPr>
             <a:r>
-              <a:t>看航点的权重占比，判断是否该少信它</a:t>
-            </a:r>
-          </a:p>
-        </p:txBody>
-      </p:sp>
-      <p:sp>
-        <p:nvSpPr>
-          <p:cNvPr id="15" name="TextBox 14"/>
+              <a:t>01 统计：航点权重能区分融合害益吗？</a:t>
+            </a:r>
+          </a:p>
+        </p:txBody>
+      </p:sp>
+      <p:sp>
+        <p:nvSpPr>
+          <p:cNvPr id="13" name="TextBox 12"/>
           <p:cNvSpPr txBox="1"/>
           <p:nvPr/>
         </p:nvSpPr>
         <p:spPr>
           <a:xfrm>
-            <a:off x="6217920" y="3712463"/>
-            <a:ext cx="5074920" cy="283464"/>
+            <a:off x="850392" y="3255264"/>
+            <a:ext cx="4974336" cy="237744"/>
           </a:xfrm>
           <a:prstGeom prst="rect">
             <a:avLst/>
@@ -4130,7 +4054,7 @@
               <a:spcAft>
                 <a:spcPts val="700"/>
               </a:spcAft>
-              <a:defRPr sz="1300" b="0">
+              <a:defRPr sz="1000" b="0">
                 <a:solidFill>
                   <a:srgbClr val="142B46"/>
                 </a:solidFill>
@@ -4138,21 +4062,21 @@
               </a:defRPr>
             </a:pPr>
             <a:r>
-              <a:t>效果变好与变差的样本，权重占比接近。</a:t>
-            </a:r>
-          </a:p>
-        </p:txBody>
-      </p:sp>
-      <p:sp>
-        <p:nvSpPr>
-          <p:cNvPr id="16" name="TextBox 15"/>
+              <a:t>r_w = κ_wp / (κ_wp + κ_g)；按 e_b &gt; e_g 分为有害组。</a:t>
+            </a:r>
+          </a:p>
+        </p:txBody>
+      </p:sp>
+      <p:sp>
+        <p:nvSpPr>
+          <p:cNvPr id="14" name="TextBox 13"/>
           <p:cNvSpPr txBox="1"/>
           <p:nvPr/>
         </p:nvSpPr>
         <p:spPr>
           <a:xfrm>
-            <a:off x="841248" y="4160520"/>
-            <a:ext cx="365760" cy="256032"/>
+            <a:off x="850392" y="3602736"/>
+            <a:ext cx="4974336" cy="219456"/>
           </a:xfrm>
           <a:prstGeom prst="rect">
             <a:avLst/>
@@ -4170,109 +4094,29 @@
               <a:spcAft>
                 <a:spcPts val="700"/>
               </a:spcAft>
-              <a:defRPr sz="1100" b="1">
+              <a:defRPr sz="1000" b="0">
                 <a:solidFill>
-                  <a:srgbClr val="148D91"/>
+                  <a:srgbClr val="62748A"/>
                 </a:solidFill>
                 <a:latin typeface="Noto Sans CJK SC"/>
               </a:defRPr>
             </a:pPr>
             <a:r>
-              <a:t>02</a:t>
-            </a:r>
-          </a:p>
-        </p:txBody>
-      </p:sp>
-      <p:sp>
-        <p:nvSpPr>
-          <p:cNvPr id="17" name="TextBox 16"/>
-          <p:cNvSpPr txBox="1"/>
-          <p:nvPr/>
-        </p:nvSpPr>
-        <p:spPr>
-          <a:xfrm>
-            <a:off x="1307592" y="4160520"/>
-            <a:ext cx="4681728" cy="283464"/>
-          </a:xfrm>
-          <a:prstGeom prst="rect">
-            <a:avLst/>
-          </a:prstGeom>
-          <a:noFill/>
-          <a:effectLst/>
-        </p:spPr>
-        <p:txBody>
-          <a:bodyPr wrap="none" lIns="0" rIns="0" tIns="0" bIns="0">
-            <a:spAutoFit/>
-          </a:bodyPr>
-          <a:lstStyle/>
-          <a:p>
-            <a:pPr>
-              <a:spcAft>
-                <a:spcPts val="700"/>
-              </a:spcAft>
-              <a:defRPr sz="1300" b="0">
-                <a:solidFill>
-                  <a:srgbClr val="142B46"/>
-                </a:solidFill>
-                <a:latin typeface="Noto Sans CJK SC"/>
-              </a:defRPr>
-            </a:pPr>
-            <a:r>
-              <a:t>训练一个模型，判断是否该只用目标方向</a:t>
-            </a:r>
-          </a:p>
-        </p:txBody>
-      </p:sp>
-      <p:sp>
-        <p:nvSpPr>
-          <p:cNvPr id="18" name="TextBox 17"/>
-          <p:cNvSpPr txBox="1"/>
-          <p:nvPr/>
-        </p:nvSpPr>
-        <p:spPr>
-          <a:xfrm>
-            <a:off x="6217920" y="4160520"/>
-            <a:ext cx="5074920" cy="283464"/>
-          </a:xfrm>
-          <a:prstGeom prst="rect">
-            <a:avLst/>
-          </a:prstGeom>
-          <a:noFill/>
-          <a:effectLst/>
-        </p:spPr>
-        <p:txBody>
-          <a:bodyPr wrap="none" lIns="0" rIns="0" tIns="0" bIns="0">
-            <a:spAutoFit/>
-          </a:bodyPr>
-          <a:lstStyle/>
-          <a:p>
-            <a:pPr>
-              <a:spcAft>
-                <a:spcPts val="700"/>
-              </a:spcAft>
-              <a:defRPr sz="1300" b="0">
-                <a:solidFill>
-                  <a:srgbClr val="142B46"/>
-                </a:solidFill>
-                <a:latin typeface="Noto Sans CJK SC"/>
-              </a:defRPr>
-            </a:pPr>
-            <a:r>
-              <a:t>判断能力接近随机猜测，未提高条件收益。</a:t>
-            </a:r>
-          </a:p>
-        </p:txBody>
-      </p:sp>
-      <p:sp>
-        <p:nvSpPr>
-          <p:cNvPr id="19" name="Rounded Rectangle 18"/>
+              <a:t>有害 / 有益组的权重份额中位数为 70.1% / 71.9%，接近。</a:t>
+            </a:r>
+          </a:p>
+        </p:txBody>
+      </p:sp>
+      <p:sp>
+        <p:nvSpPr>
+          <p:cNvPr id="15" name="Rounded Rectangle 14"/>
           <p:cNvSpPr/>
           <p:nvPr/>
         </p:nvSpPr>
         <p:spPr>
           <a:xfrm>
-            <a:off x="685800" y="4571999"/>
-            <a:ext cx="10826496" cy="411480"/>
+            <a:off x="6208776" y="2734056"/>
+            <a:ext cx="5303520" cy="1197864"/>
           </a:xfrm>
           <a:prstGeom prst="roundRect">
             <a:avLst>
@@ -4311,14 +4155,14 @@
       </p:sp>
       <p:sp>
         <p:nvSpPr>
-          <p:cNvPr id="20" name="TextBox 19"/>
+          <p:cNvPr id="16" name="TextBox 15"/>
           <p:cNvSpPr txBox="1"/>
           <p:nvPr/>
         </p:nvSpPr>
         <p:spPr>
           <a:xfrm>
-            <a:off x="841248" y="4608575"/>
-            <a:ext cx="365760" cy="256032"/>
+            <a:off x="6373368" y="2834640"/>
+            <a:ext cx="4974336" cy="274320"/>
           </a:xfrm>
           <a:prstGeom prst="rect">
             <a:avLst/>
@@ -4336,47 +4180,7 @@
               <a:spcAft>
                 <a:spcPts val="700"/>
               </a:spcAft>
-              <a:defRPr sz="1100" b="1">
-                <a:solidFill>
-                  <a:srgbClr val="148D91"/>
-                </a:solidFill>
-                <a:latin typeface="Noto Sans CJK SC"/>
-              </a:defRPr>
-            </a:pPr>
-            <a:r>
-              <a:t>03</a:t>
-            </a:r>
-          </a:p>
-        </p:txBody>
-      </p:sp>
-      <p:sp>
-        <p:nvSpPr>
-          <p:cNvPr id="21" name="TextBox 20"/>
-          <p:cNvSpPr txBox="1"/>
-          <p:nvPr/>
-        </p:nvSpPr>
-        <p:spPr>
-          <a:xfrm>
-            <a:off x="1307592" y="4608575"/>
-            <a:ext cx="4681728" cy="283464"/>
-          </a:xfrm>
-          <a:prstGeom prst="rect">
-            <a:avLst/>
-          </a:prstGeom>
-          <a:noFill/>
-          <a:effectLst/>
-        </p:spPr>
-        <p:txBody>
-          <a:bodyPr wrap="none" lIns="0" rIns="0" tIns="0" bIns="0">
-            <a:spAutoFit/>
-          </a:bodyPr>
-          <a:lstStyle/>
-          <a:p>
-            <a:pPr>
-              <a:spcAft>
-                <a:spcPts val="700"/>
-              </a:spcAft>
-              <a:defRPr sz="1300" b="0">
+              <a:defRPr sz="1400" b="1">
                 <a:solidFill>
                   <a:srgbClr val="142B46"/>
                 </a:solidFill>
@@ -4384,21 +4188,21 @@
               </a:defRPr>
             </a:pPr>
             <a:r>
-              <a:t>让模型自动降低航点的影响</a:t>
-            </a:r>
-          </a:p>
-        </p:txBody>
-      </p:sp>
-      <p:sp>
-        <p:nvSpPr>
-          <p:cNvPr id="22" name="TextBox 21"/>
+              <a:t>02 分类：预测是否改用目标方向</a:t>
+            </a:r>
+          </a:p>
+        </p:txBody>
+      </p:sp>
+      <p:sp>
+        <p:nvSpPr>
+          <p:cNvPr id="17" name="TextBox 16"/>
           <p:cNvSpPr txBox="1"/>
           <p:nvPr/>
         </p:nvSpPr>
         <p:spPr>
           <a:xfrm>
-            <a:off x="6217920" y="4608575"/>
-            <a:ext cx="5074920" cy="283464"/>
+            <a:off x="6373368" y="3218688"/>
+            <a:ext cx="4974336" cy="210312"/>
           </a:xfrm>
           <a:prstGeom prst="rect">
             <a:avLst/>
@@ -4416,7 +4220,7 @@
               <a:spcAft>
                 <a:spcPts val="700"/>
               </a:spcAft>
-              <a:defRPr sz="1300" b="0">
+              <a:defRPr sz="1000" b="0">
                 <a:solidFill>
                   <a:srgbClr val="142B46"/>
                 </a:solidFill>
@@ -4424,21 +4228,21 @@
               </a:defRPr>
             </a:pPr>
             <a:r>
-              <a:t>模型几乎不作调整，效果接近原方法。</a:t>
-            </a:r>
-          </a:p>
-        </p:txBody>
-      </p:sp>
-      <p:sp>
-        <p:nvSpPr>
-          <p:cNvPr id="23" name="TextBox 22"/>
+              <a:t>标签 y=1[e_b&gt;e_g]；用夹角、κ 等特征训练逻辑回归。</a:t>
+            </a:r>
+          </a:p>
+        </p:txBody>
+      </p:sp>
+      <p:sp>
+        <p:nvSpPr>
+          <p:cNvPr id="18" name="TextBox 17"/>
           <p:cNvSpPr txBox="1"/>
           <p:nvPr/>
         </p:nvSpPr>
         <p:spPr>
           <a:xfrm>
-            <a:off x="841248" y="5056631"/>
-            <a:ext cx="365760" cy="256032"/>
+            <a:off x="6373368" y="3511296"/>
+            <a:ext cx="4974336" cy="210312"/>
           </a:xfrm>
           <a:prstGeom prst="rect">
             <a:avLst/>
@@ -4456,47 +4260,7 @@
               <a:spcAft>
                 <a:spcPts val="700"/>
               </a:spcAft>
-              <a:defRPr sz="1100" b="1">
-                <a:solidFill>
-                  <a:srgbClr val="148D91"/>
-                </a:solidFill>
-                <a:latin typeface="Noto Sans CJK SC"/>
-              </a:defRPr>
-            </a:pPr>
-            <a:r>
-              <a:t>04</a:t>
-            </a:r>
-          </a:p>
-        </p:txBody>
-      </p:sp>
-      <p:sp>
-        <p:nvSpPr>
-          <p:cNvPr id="24" name="TextBox 23"/>
-          <p:cNvSpPr txBox="1"/>
-          <p:nvPr/>
-        </p:nvSpPr>
-        <p:spPr>
-          <a:xfrm>
-            <a:off x="1307592" y="5056631"/>
-            <a:ext cx="4681728" cy="283464"/>
-          </a:xfrm>
-          <a:prstGeom prst="rect">
-            <a:avLst/>
-          </a:prstGeom>
-          <a:noFill/>
-          <a:effectLst/>
-        </p:spPr>
-        <p:txBody>
-          <a:bodyPr wrap="none" lIns="0" rIns="0" tIns="0" bIns="0">
-            <a:spAutoFit/>
-          </a:bodyPr>
-          <a:lstStyle/>
-          <a:p>
-            <a:pPr>
-              <a:spcAft>
-                <a:spcPts val="700"/>
-              </a:spcAft>
-              <a:defRPr sz="1300" b="0">
+              <a:defRPr sz="1000" b="0">
                 <a:solidFill>
                   <a:srgbClr val="142B46"/>
                 </a:solidFill>
@@ -4504,21 +4268,21 @@
               </a:defRPr>
             </a:pPr>
             <a:r>
-              <a:t>两种方向分歧大时，就减少航点权重</a:t>
-            </a:r>
-          </a:p>
-        </p:txBody>
-      </p:sp>
-      <p:sp>
-        <p:nvSpPr>
-          <p:cNvPr id="25" name="TextBox 24"/>
+              <a:t>预测有害概率 ≥0.60 则只用目标方向，否则保留融合。</a:t>
+            </a:r>
+          </a:p>
+        </p:txBody>
+      </p:sp>
+      <p:sp>
+        <p:nvSpPr>
+          <p:cNvPr id="19" name="TextBox 18"/>
           <p:cNvSpPr txBox="1"/>
           <p:nvPr/>
         </p:nvSpPr>
         <p:spPr>
           <a:xfrm>
-            <a:off x="6217920" y="5056631"/>
-            <a:ext cx="5074920" cy="283464"/>
+            <a:off x="6373368" y="3767328"/>
+            <a:ext cx="4974336" cy="164592"/>
           </a:xfrm>
           <a:prstGeom prst="rect">
             <a:avLst/>
@@ -4536,47 +4300,7 @@
               <a:spcAft>
                 <a:spcPts val="700"/>
               </a:spcAft>
-              <a:defRPr sz="1300" b="1">
-                <a:solidFill>
-                  <a:srgbClr val="148D91"/>
-                </a:solidFill>
-                <a:latin typeface="Noto Sans CJK SC"/>
-              </a:defRPr>
-            </a:pPr>
-            <a:r>
-              <a:t>条件收益从 2.80 降至 2.24 cm，反而更差。</a:t>
-            </a:r>
-          </a:p>
-        </p:txBody>
-      </p:sp>
-      <p:sp>
-        <p:nvSpPr>
-          <p:cNvPr id="26" name="TextBox 25"/>
-          <p:cNvSpPr txBox="1"/>
-          <p:nvPr/>
-        </p:nvSpPr>
-        <p:spPr>
-          <a:xfrm>
-            <a:off x="685800" y="5596128"/>
-            <a:ext cx="10826496" cy="256032"/>
-          </a:xfrm>
-          <a:prstGeom prst="rect">
-            <a:avLst/>
-          </a:prstGeom>
-          <a:noFill/>
-          <a:effectLst/>
-        </p:spPr>
-        <p:txBody>
-          <a:bodyPr wrap="none" lIns="0" rIns="0" tIns="0" bIns="0">
-            <a:spAutoFit/>
-          </a:bodyPr>
-          <a:lstStyle/>
-          <a:p>
-            <a:pPr>
-              <a:spcAft>
-                <a:spcPts val="700"/>
-              </a:spcAft>
-              <a:defRPr sz="1000" b="0">
+              <a:defRPr sz="900" b="0">
                 <a:solidFill>
                   <a:srgbClr val="62748A"/>
                 </a:solidFill>
@@ -4584,61 +4308,21 @@
               </a:defRPr>
             </a:pPr>
             <a:r>
-              <a:t>说明：条件收益表示加入目标信息后误差减少了多少，越大越好；上述结果分别与各自的原方法比较。</a:t>
-            </a:r>
-          </a:p>
-        </p:txBody>
-      </p:sp>
-      <p:sp>
-        <p:nvSpPr>
-          <p:cNvPr id="27" name="TextBox 26"/>
-          <p:cNvSpPr txBox="1"/>
-          <p:nvPr/>
-        </p:nvSpPr>
-        <p:spPr>
-          <a:xfrm>
-            <a:off x="685800" y="5907024"/>
-            <a:ext cx="10826496" cy="246888"/>
-          </a:xfrm>
-          <a:prstGeom prst="rect">
-            <a:avLst/>
-          </a:prstGeom>
-          <a:noFill/>
-          <a:effectLst/>
-        </p:spPr>
-        <p:txBody>
-          <a:bodyPr wrap="none" lIns="0" rIns="0" tIns="0" bIns="0">
-            <a:spAutoFit/>
-          </a:bodyPr>
-          <a:lstStyle/>
-          <a:p>
-            <a:pPr>
-              <a:spcAft>
-                <a:spcPts val="700"/>
-              </a:spcAft>
-              <a:defRPr sz="1000" b="0">
-                <a:solidFill>
-                  <a:srgbClr val="62748A"/>
-                </a:solidFill>
-                <a:latin typeface="Noto Sans CJK SC"/>
-              </a:defRPr>
-            </a:pPr>
-            <a:r>
-              <a:t>其中部分模型使用了真实未来轨迹信息，仅为离线分析，尚不能直接用于实机。</a:t>
-            </a:r>
-          </a:p>
-        </p:txBody>
-      </p:sp>
-      <p:sp>
-        <p:nvSpPr>
-          <p:cNvPr id="28" name="Rounded Rectangle 27"/>
+              <a:t>本批阈值下没有帧被切换；AUC=0.52，判断接近随机。</a:t>
+            </a:r>
+          </a:p>
+        </p:txBody>
+      </p:sp>
+      <p:sp>
+        <p:nvSpPr>
+          <p:cNvPr id="20" name="Rounded Rectangle 19"/>
           <p:cNvSpPr/>
           <p:nvPr/>
         </p:nvSpPr>
         <p:spPr>
           <a:xfrm>
-            <a:off x="685800" y="6254496"/>
-            <a:ext cx="10826496" cy="365760"/>
+            <a:off x="685800" y="4096512"/>
+            <a:ext cx="5303520" cy="1490472"/>
           </a:xfrm>
           <a:prstGeom prst="roundRect">
             <a:avLst>
@@ -4646,7 +4330,7 @@
             </a:avLst>
           </a:prstGeom>
           <a:solidFill>
-            <a:srgbClr val="E8F4F2"/>
+            <a:srgbClr val="ECF1F7"/>
           </a:solidFill>
           <a:ln>
             <a:noFill/>
@@ -4677,14 +4361,14 @@
       </p:sp>
       <p:sp>
         <p:nvSpPr>
-          <p:cNvPr id="29" name="TextBox 28"/>
+          <p:cNvPr id="21" name="TextBox 20"/>
           <p:cNvSpPr txBox="1"/>
           <p:nvPr/>
         </p:nvSpPr>
         <p:spPr>
           <a:xfrm>
-            <a:off x="859536" y="6309360"/>
-            <a:ext cx="10424160" cy="256032"/>
+            <a:off x="850392" y="4206240"/>
+            <a:ext cx="4974336" cy="274320"/>
           </a:xfrm>
           <a:prstGeom prst="rect">
             <a:avLst/>
@@ -4702,7 +4386,253 @@
               <a:spcAft>
                 <a:spcPts val="700"/>
               </a:spcAft>
-              <a:defRPr sz="1400" b="1">
+              <a:defRPr sz="1300" b="1">
+                <a:solidFill>
+                  <a:srgbClr val="142B46"/>
+                </a:solidFill>
+                <a:latin typeface="Noto Sans CJK SC"/>
+              </a:defRPr>
+            </a:pPr>
+            <a:r>
+              <a:t>03 回归：用两端误差近似制作抑制标签</a:t>
+            </a:r>
+          </a:p>
+        </p:txBody>
+      </p:sp>
+      <p:sp>
+        <p:nvSpPr>
+          <p:cNvPr id="22" name="TextBox 21"/>
+          <p:cNvSpPr txBox="1"/>
+          <p:nvPr/>
+        </p:nvSpPr>
+        <p:spPr>
+          <a:xfrm>
+            <a:off x="850392" y="4581144"/>
+            <a:ext cx="4974336" cy="219456"/>
+          </a:xfrm>
+          <a:prstGeom prst="rect">
+            <a:avLst/>
+          </a:prstGeom>
+          <a:noFill/>
+          <a:effectLst/>
+        </p:spPr>
+        <p:txBody>
+          <a:bodyPr wrap="none" lIns="0" rIns="0" tIns="0" bIns="0">
+            <a:spAutoFit/>
+          </a:bodyPr>
+          <a:lstStyle/>
+          <a:p>
+            <a:pPr>
+              <a:spcAft>
+                <a:spcPts val="700"/>
+              </a:spcAft>
+              <a:defRPr sz="1100" b="0">
+                <a:solidFill>
+                  <a:srgbClr val="142B46"/>
+                </a:solidFill>
+                <a:latin typeface="Noto Sans CJK SC"/>
+              </a:defRPr>
+            </a:pPr>
+            <a:r>
+              <a:t>s∈{0,0.05,…,1}；ẽ(s)=(1−s)e_b+s e_g。</a:t>
+            </a:r>
+          </a:p>
+        </p:txBody>
+      </p:sp>
+      <p:sp>
+        <p:nvSpPr>
+          <p:cNvPr id="23" name="TextBox 22"/>
+          <p:cNvSpPr txBox="1"/>
+          <p:nvPr/>
+        </p:nvSpPr>
+        <p:spPr>
+          <a:xfrm>
+            <a:off x="850392" y="4864608"/>
+            <a:ext cx="4974336" cy="210312"/>
+          </a:xfrm>
+          <a:prstGeom prst="rect">
+            <a:avLst/>
+          </a:prstGeom>
+          <a:noFill/>
+          <a:effectLst/>
+        </p:spPr>
+        <p:txBody>
+          <a:bodyPr wrap="none" lIns="0" rIns="0" tIns="0" bIns="0">
+            <a:spAutoFit/>
+          </a:bodyPr>
+          <a:lstStyle/>
+          <a:p>
+            <a:pPr>
+              <a:spcAft>
+                <a:spcPts val="700"/>
+              </a:spcAft>
+              <a:defRPr sz="1000" b="0">
+                <a:solidFill>
+                  <a:srgbClr val="142B46"/>
+                </a:solidFill>
+                <a:latin typeface="Noto Sans CJK SC"/>
+              </a:defRPr>
+            </a:pPr>
+            <a:r>
+              <a:t>选误差最小的 s* 作标签；直线最优通常只在 0 或 1。</a:t>
+            </a:r>
+          </a:p>
+        </p:txBody>
+      </p:sp>
+      <p:sp>
+        <p:nvSpPr>
+          <p:cNvPr id="24" name="TextBox 23"/>
+          <p:cNvSpPr txBox="1"/>
+          <p:nvPr/>
+        </p:nvSpPr>
+        <p:spPr>
+          <a:xfrm>
+            <a:off x="850392" y="5129784"/>
+            <a:ext cx="4974336" cy="210312"/>
+          </a:xfrm>
+          <a:prstGeom prst="rect">
+            <a:avLst/>
+          </a:prstGeom>
+          <a:noFill/>
+          <a:effectLst/>
+        </p:spPr>
+        <p:txBody>
+          <a:bodyPr wrap="none" lIns="0" rIns="0" tIns="0" bIns="0">
+            <a:spAutoFit/>
+          </a:bodyPr>
+          <a:lstStyle/>
+          <a:p>
+            <a:pPr>
+              <a:spcAft>
+                <a:spcPts val="700"/>
+              </a:spcAft>
+              <a:defRPr sz="1000" b="0">
+                <a:solidFill>
+                  <a:srgbClr val="62748A"/>
+                </a:solidFill>
+                <a:latin typeface="Noto Sans CJK SC"/>
+              </a:defRPr>
+            </a:pPr>
+            <a:r>
+              <a:t>未逐一重跑 21 个强度；岭回归预测 ŝ，再截到 [0,1]。</a:t>
+            </a:r>
+          </a:p>
+        </p:txBody>
+      </p:sp>
+      <p:sp>
+        <p:nvSpPr>
+          <p:cNvPr id="25" name="TextBox 24"/>
+          <p:cNvSpPr txBox="1"/>
+          <p:nvPr/>
+        </p:nvSpPr>
+        <p:spPr>
+          <a:xfrm>
+            <a:off x="850392" y="5394960"/>
+            <a:ext cx="4974336" cy="173736"/>
+          </a:xfrm>
+          <a:prstGeom prst="rect">
+            <a:avLst/>
+          </a:prstGeom>
+          <a:noFill/>
+          <a:effectLst/>
+        </p:spPr>
+        <p:txBody>
+          <a:bodyPr wrap="none" lIns="0" rIns="0" tIns="0" bIns="0">
+            <a:spAutoFit/>
+          </a:bodyPr>
+          <a:lstStyle/>
+          <a:p>
+            <a:pPr>
+              <a:spcAft>
+                <a:spcPts val="700"/>
+              </a:spcAft>
+              <a:defRPr sz="900" b="1">
+                <a:solidFill>
+                  <a:srgbClr val="8C5E27"/>
+                </a:solidFill>
+                <a:latin typeface="Noto Sans CJK SC"/>
+              </a:defRPr>
+            </a:pPr>
+            <a:r>
+              <a:t>核查发现回归缺截距：低抑制输出不能直接作为方法结论。</a:t>
+            </a:r>
+          </a:p>
+        </p:txBody>
+      </p:sp>
+      <p:sp>
+        <p:nvSpPr>
+          <p:cNvPr id="26" name="Rounded Rectangle 25"/>
+          <p:cNvSpPr/>
+          <p:nvPr/>
+        </p:nvSpPr>
+        <p:spPr>
+          <a:xfrm>
+            <a:off x="6208776" y="4096512"/>
+            <a:ext cx="5303520" cy="1490472"/>
+          </a:xfrm>
+          <a:prstGeom prst="roundRect">
+            <a:avLst>
+              <a:gd name="adj" fmla="val 12000"/>
+            </a:avLst>
+          </a:prstGeom>
+          <a:solidFill>
+            <a:srgbClr val="E8F4F2"/>
+          </a:solidFill>
+          <a:ln>
+            <a:noFill/>
+          </a:ln>
+          <a:effectLst/>
+        </p:spPr>
+        <p:style>
+          <a:lnRef idx="1">
+            <a:schemeClr val="accent1"/>
+          </a:lnRef>
+          <a:fillRef idx="3">
+            <a:schemeClr val="accent1"/>
+          </a:fillRef>
+          <a:effectRef idx="0">
+            <a:schemeClr val="accent1"/>
+          </a:effectRef>
+          <a:fontRef idx="minor">
+            <a:schemeClr val="lt1"/>
+          </a:fontRef>
+        </p:style>
+        <p:txBody>
+          <a:bodyPr rtlCol="0" anchor="ctr"/>
+          <a:lstStyle/>
+          <a:p>
+            <a:pPr algn="ctr"/>
+          </a:p>
+        </p:txBody>
+      </p:sp>
+      <p:sp>
+        <p:nvSpPr>
+          <p:cNvPr id="27" name="TextBox 26"/>
+          <p:cNvSpPr txBox="1"/>
+          <p:nvPr/>
+        </p:nvSpPr>
+        <p:spPr>
+          <a:xfrm>
+            <a:off x="6373368" y="4206240"/>
+            <a:ext cx="4974336" cy="274320"/>
+          </a:xfrm>
+          <a:prstGeom prst="rect">
+            <a:avLst/>
+          </a:prstGeom>
+          <a:noFill/>
+          <a:effectLst/>
+        </p:spPr>
+        <p:txBody>
+          <a:bodyPr wrap="none" lIns="0" rIns="0" tIns="0" bIns="0">
+            <a:spAutoFit/>
+          </a:bodyPr>
+          <a:lstStyle/>
+          <a:p>
+            <a:pPr>
+              <a:spcAft>
+                <a:spcPts val="700"/>
+              </a:spcAft>
+              <a:defRPr sz="1300" b="1">
                 <a:solidFill>
                   <a:srgbClr val="148D91"/>
                 </a:solidFill>
@@ -4710,21 +4640,21 @@
               </a:defRPr>
             </a:pPr>
             <a:r>
-              <a:t>启示：先把航点方向预测得更准，比继续增加这些判断规则更值得优先尝试。</a:t>
-            </a:r>
-          </a:p>
-        </p:txBody>
-      </p:sp>
-      <p:sp>
-        <p:nvSpPr>
-          <p:cNvPr id="30" name="TextBox 29"/>
+              <a:t>04 规则：按两个预测方向的分歧降权</a:t>
+            </a:r>
+          </a:p>
+        </p:txBody>
+      </p:sp>
+      <p:sp>
+        <p:nvSpPr>
+          <p:cNvPr id="28" name="TextBox 27"/>
           <p:cNvSpPr txBox="1"/>
           <p:nvPr/>
         </p:nvSpPr>
         <p:spPr>
           <a:xfrm>
-            <a:off x="685800" y="6684264"/>
-            <a:ext cx="10058400" cy="146304"/>
+            <a:off x="6373368" y="4581144"/>
+            <a:ext cx="4974336" cy="219456"/>
           </a:xfrm>
           <a:prstGeom prst="rect">
             <a:avLst/>
@@ -4742,7 +4672,87 @@
               <a:spcAft>
                 <a:spcPts val="700"/>
               </a:spcAft>
-              <a:defRPr sz="800" b="0">
+              <a:defRPr sz="1100" b="1">
+                <a:solidFill>
+                  <a:srgbClr val="148D91"/>
+                </a:solidFill>
+                <a:latin typeface="Noto Sans CJK SC"/>
+              </a:defRPr>
+            </a:pPr>
+            <a:r>
+              <a:t>θ=arccos(d_g·d_wp)；s=clip((θ−35°)/20°, 0, 1)。</a:t>
+            </a:r>
+          </a:p>
+        </p:txBody>
+      </p:sp>
+      <p:sp>
+        <p:nvSpPr>
+          <p:cNvPr id="29" name="TextBox 28"/>
+          <p:cNvSpPr txBox="1"/>
+          <p:nvPr/>
+        </p:nvSpPr>
+        <p:spPr>
+          <a:xfrm>
+            <a:off x="6373368" y="4864608"/>
+            <a:ext cx="4974336" cy="210312"/>
+          </a:xfrm>
+          <a:prstGeom prst="rect">
+            <a:avLst/>
+          </a:prstGeom>
+          <a:noFill/>
+          <a:effectLst/>
+        </p:spPr>
+        <p:txBody>
+          <a:bodyPr wrap="none" lIns="0" rIns="0" tIns="0" bIns="0">
+            <a:spAutoFit/>
+          </a:bodyPr>
+          <a:lstStyle/>
+          <a:p>
+            <a:pPr>
+              <a:spcAft>
+                <a:spcPts val="700"/>
+              </a:spcAft>
+              <a:defRPr sz="1000" b="0">
+                <a:solidFill>
+                  <a:srgbClr val="142B46"/>
+                </a:solidFill>
+                <a:latin typeface="Noto Sans CJK SC"/>
+              </a:defRPr>
+            </a:pPr>
+            <a:r>
+              <a:t>θ≤35°：不降权；θ=45°：减半；θ≥55°：只用目标。</a:t>
+            </a:r>
+          </a:p>
+        </p:txBody>
+      </p:sp>
+      <p:sp>
+        <p:nvSpPr>
+          <p:cNvPr id="30" name="TextBox 29"/>
+          <p:cNvSpPr txBox="1"/>
+          <p:nvPr/>
+        </p:nvSpPr>
+        <p:spPr>
+          <a:xfrm>
+            <a:off x="6373368" y="5129784"/>
+            <a:ext cx="4974336" cy="210312"/>
+          </a:xfrm>
+          <a:prstGeom prst="rect">
+            <a:avLst/>
+          </a:prstGeom>
+          <a:noFill/>
+          <a:effectLst/>
+        </p:spPr>
+        <p:txBody>
+          <a:bodyPr wrap="none" lIns="0" rIns="0" tIns="0" bIns="0">
+            <a:spAutoFit/>
+          </a:bodyPr>
+          <a:lstStyle/>
+          <a:p>
+            <a:pPr>
+              <a:spcAft>
+                <a:spcPts val="700"/>
+              </a:spcAft>
+              <a:defRPr sz="1000" b="0">
                 <a:solidFill>
                   <a:srgbClr val="62748A"/>
                 </a:solidFill>
@@ -4750,7 +4760,7 @@
               </a:defRPr>
             </a:pPr>
             <a:r>
-              <a:t>来源：p5ab_summary.txt、p5b/c summary.json、kappa_fusion_summary.txt；技术细节与评估口径见备注。</a:t>
+              <a:t>35°–55° 原由真实 WP 误差选出，不能直接等同预测分歧。</a:t>
             </a:r>
           </a:p>
         </p:txBody>
@@ -4763,8 +4773,8 @@
         </p:nvSpPr>
         <p:spPr>
           <a:xfrm>
-            <a:off x="10506456" y="6684264"/>
-            <a:ext cx="960120" cy="146304"/>
+            <a:off x="6373368" y="5394960"/>
+            <a:ext cx="4974336" cy="173736"/>
           </a:xfrm>
           <a:prstGeom prst="rect">
             <a:avLst/>
@@ -4782,7 +4792,213 @@
               <a:spcAft>
                 <a:spcPts val="700"/>
               </a:spcAft>
-              <a:defRPr sz="800" b="0">
+              <a:defRPr sz="900" b="1">
+                <a:solidFill>
+                  <a:srgbClr val="148D91"/>
+                </a:solidFill>
+                <a:latin typeface="Noto Sans CJK SC"/>
+              </a:defRPr>
+            </a:pPr>
+            <a:r>
+              <a:t>同批条件收益：2.80 → 2.24 cm，固定分歧规则反而更差。</a:t>
+            </a:r>
+          </a:p>
+        </p:txBody>
+      </p:sp>
+      <p:sp>
+        <p:nvSpPr>
+          <p:cNvPr id="32" name="Rounded Rectangle 31"/>
+          <p:cNvSpPr/>
+          <p:nvPr/>
+        </p:nvSpPr>
+        <p:spPr>
+          <a:xfrm>
+            <a:off x="685800" y="5760720"/>
+            <a:ext cx="10826496" cy="402336"/>
+          </a:xfrm>
+          <a:prstGeom prst="roundRect">
+            <a:avLst>
+              <a:gd name="adj" fmla="val 12000"/>
+            </a:avLst>
+          </a:prstGeom>
+          <a:solidFill>
+            <a:srgbClr val="E8F4F2"/>
+          </a:solidFill>
+          <a:ln>
+            <a:noFill/>
+          </a:ln>
+          <a:effectLst/>
+        </p:spPr>
+        <p:style>
+          <a:lnRef idx="1">
+            <a:schemeClr val="accent1"/>
+          </a:lnRef>
+          <a:fillRef idx="3">
+            <a:schemeClr val="accent1"/>
+          </a:fillRef>
+          <a:effectRef idx="0">
+            <a:schemeClr val="accent1"/>
+          </a:effectRef>
+          <a:fontRef idx="minor">
+            <a:schemeClr val="lt1"/>
+          </a:fontRef>
+        </p:style>
+        <p:txBody>
+          <a:bodyPr rtlCol="0" anchor="ctr"/>
+          <a:lstStyle/>
+          <a:p>
+            <a:pPr algn="ctr"/>
+          </a:p>
+        </p:txBody>
+      </p:sp>
+      <p:sp>
+        <p:nvSpPr>
+          <p:cNvPr id="33" name="TextBox 32"/>
+          <p:cNvSpPr txBox="1"/>
+          <p:nvPr/>
+        </p:nvSpPr>
+        <p:spPr>
+          <a:xfrm>
+            <a:off x="859536" y="5843016"/>
+            <a:ext cx="10424160" cy="265176"/>
+          </a:xfrm>
+          <a:prstGeom prst="rect">
+            <a:avLst/>
+          </a:prstGeom>
+          <a:noFill/>
+          <a:effectLst/>
+        </p:spPr>
+        <p:txBody>
+          <a:bodyPr wrap="none" lIns="0" rIns="0" tIns="0" bIns="0">
+            <a:spAutoFit/>
+          </a:bodyPr>
+          <a:lstStyle/>
+          <a:p>
+            <a:pPr>
+              <a:spcAft>
+                <a:spcPts val="700"/>
+              </a:spcAft>
+              <a:defRPr sz="1200" b="1">
+                <a:solidFill>
+                  <a:srgbClr val="148D91"/>
+                </a:solidFill>
+                <a:latin typeface="Noto Sans CJK SC"/>
+              </a:defRPr>
+            </a:pPr>
+            <a:r>
+              <a:t>03 / 04 实际降权：κ′_wp=(1−s)κ_wp；d=normalize(κ_g d_g + κ′_wp d_wp)；位置条件=B 距离×d。</a:t>
+            </a:r>
+          </a:p>
+        </p:txBody>
+      </p:sp>
+      <p:sp>
+        <p:nvSpPr>
+          <p:cNvPr id="34" name="TextBox 33"/>
+          <p:cNvSpPr txBox="1"/>
+          <p:nvPr/>
+        </p:nvSpPr>
+        <p:spPr>
+          <a:xfrm>
+            <a:off x="685800" y="6318504"/>
+            <a:ext cx="10826496" cy="210312"/>
+          </a:xfrm>
+          <a:prstGeom prst="rect">
+            <a:avLst/>
+          </a:prstGeom>
+          <a:noFill/>
+          <a:effectLst/>
+        </p:spPr>
+        <p:txBody>
+          <a:bodyPr wrap="none" lIns="0" rIns="0" tIns="0" bIns="0">
+            <a:spAutoFit/>
+          </a:bodyPr>
+          <a:lstStyle/>
+          <a:p>
+            <a:pPr>
+              <a:spcAft>
+                <a:spcPts val="700"/>
+              </a:spcAft>
+              <a:defRPr sz="1000" b="0">
+                <a:solidFill>
+                  <a:srgbClr val="62748A"/>
+                </a:solidFill>
+                <a:latin typeface="Noto Sans CJK SC"/>
+              </a:defRPr>
+            </a:pPr>
+            <a:r>
+              <a:t>边界：02 / 03 的特征含真实未来运动信息；03 需修正截距后重评；这些结果不能当作实机有效性证明。</a:t>
+            </a:r>
+          </a:p>
+        </p:txBody>
+      </p:sp>
+      <p:sp>
+        <p:nvSpPr>
+          <p:cNvPr id="35" name="TextBox 34"/>
+          <p:cNvSpPr txBox="1"/>
+          <p:nvPr/>
+        </p:nvSpPr>
+        <p:spPr>
+          <a:xfrm>
+            <a:off x="685800" y="6693408"/>
+            <a:ext cx="10058400" cy="146304"/>
+          </a:xfrm>
+          <a:prstGeom prst="rect">
+            <a:avLst/>
+          </a:prstGeom>
+          <a:noFill/>
+          <a:effectLst/>
+        </p:spPr>
+        <p:txBody>
+          <a:bodyPr wrap="none" lIns="0" rIns="0" tIns="0" bIns="0">
+            <a:spAutoFit/>
+          </a:bodyPr>
+          <a:lstStyle/>
+          <a:p>
+            <a:pPr>
+              <a:spcAft>
+                <a:spcPts val="700"/>
+              </a:spcAft>
+              <a:defRPr sz="700" b="0">
+                <a:solidFill>
+                  <a:srgbClr val="62748A"/>
+                </a:solidFill>
+                <a:latin typeface="Noto Sans CJK SC"/>
+              </a:defRPr>
+            </a:pPr>
+            <a:r>
+              <a:t>来源：eval_by_distance.py、eval_testtime.py、run_p5b_harmful_predictor.py、run_p5c_trust.py、adaptive_blend.py。</a:t>
+            </a:r>
+          </a:p>
+        </p:txBody>
+      </p:sp>
+      <p:sp>
+        <p:nvSpPr>
+          <p:cNvPr id="36" name="TextBox 35"/>
+          <p:cNvSpPr txBox="1"/>
+          <p:nvPr/>
+        </p:nvSpPr>
+        <p:spPr>
+          <a:xfrm>
+            <a:off x="10506456" y="6693408"/>
+            <a:ext cx="960120" cy="146304"/>
+          </a:xfrm>
+          <a:prstGeom prst="rect">
+            <a:avLst/>
+          </a:prstGeom>
+          <a:noFill/>
+          <a:effectLst/>
+        </p:spPr>
+        <p:txBody>
+          <a:bodyPr wrap="none" lIns="0" rIns="0" tIns="0" bIns="0">
+            <a:spAutoFit/>
+          </a:bodyPr>
+          <a:lstStyle/>
+          <a:p>
+            <a:pPr>
+              <a:spcAft>
+                <a:spcPts val="700"/>
+              </a:spcAft>
+              <a:defRPr sz="700" b="0">
                 <a:solidFill>
                   <a:srgbClr val="62748A"/>
                 </a:solidFill>

</xml_diff>